<commit_message>
restructure -- mostly correct now
</commit_message>
<xml_diff>
--- a/Presentation1.pptx
+++ b/Presentation1.pptx
@@ -6,14 +6,18 @@
   </p:sldMasterIdLst>
   <p:sldIdLst>
     <p:sldId id="256" r:id="rId2"/>
-    <p:sldId id="260" r:id="rId3"/>
-    <p:sldId id="257" r:id="rId4"/>
-    <p:sldId id="258" r:id="rId5"/>
-    <p:sldId id="259" r:id="rId6"/>
-    <p:sldId id="261" r:id="rId7"/>
-    <p:sldId id="262" r:id="rId8"/>
-    <p:sldId id="263" r:id="rId9"/>
-    <p:sldId id="264" r:id="rId10"/>
+    <p:sldId id="265" r:id="rId3"/>
+    <p:sldId id="260" r:id="rId4"/>
+    <p:sldId id="257" r:id="rId5"/>
+    <p:sldId id="266" r:id="rId6"/>
+    <p:sldId id="258" r:id="rId7"/>
+    <p:sldId id="267" r:id="rId8"/>
+    <p:sldId id="268" r:id="rId9"/>
+    <p:sldId id="270" r:id="rId10"/>
+    <p:sldId id="261" r:id="rId11"/>
+    <p:sldId id="262" r:id="rId12"/>
+    <p:sldId id="263" r:id="rId13"/>
+    <p:sldId id="264" r:id="rId14"/>
   </p:sldIdLst>
   <p:sldSz cx="12192000" cy="6858000"/>
   <p:notesSz cx="6858000" cy="9144000"/>
@@ -3955,7 +3959,706 @@
 </p:sld>
 </file>
 
+<file path=ppt/slides/slide10.xml><?xml version="1.0" encoding="utf-8"?>
+<p:sld xmlns:a="http://schemas.openxmlformats.org/drawingml/2006/main" xmlns:r="http://schemas.openxmlformats.org/officeDocument/2006/relationships" xmlns:p="http://schemas.openxmlformats.org/presentationml/2006/main">
+  <p:cSld>
+    <p:spTree>
+      <p:nvGrpSpPr>
+        <p:cNvPr id="1" name=""/>
+        <p:cNvGrpSpPr/>
+        <p:nvPr/>
+      </p:nvGrpSpPr>
+      <p:grpSpPr>
+        <a:xfrm>
+          <a:off x="0" y="0"/>
+          <a:ext cx="0" cy="0"/>
+          <a:chOff x="0" y="0"/>
+          <a:chExt cx="0" cy="0"/>
+        </a:xfrm>
+      </p:grpSpPr>
+      <p:sp>
+        <p:nvSpPr>
+          <p:cNvPr id="2" name="Title 1">
+            <a:extLst>
+              <a:ext uri="{FF2B5EF4-FFF2-40B4-BE49-F238E27FC236}">
+                <a16:creationId xmlns:a16="http://schemas.microsoft.com/office/drawing/2014/main" id="{515984D7-D2CE-D5F3-4D33-71550CF3C5CB}"/>
+              </a:ext>
+            </a:extLst>
+          </p:cNvPr>
+          <p:cNvSpPr>
+            <a:spLocks noGrp="1"/>
+          </p:cNvSpPr>
+          <p:nvPr>
+            <p:ph type="title"/>
+          </p:nvPr>
+        </p:nvSpPr>
+        <p:spPr/>
+        <p:txBody>
+          <a:bodyPr/>
+          <a:lstStyle/>
+          <a:p>
+            <a:r>
+              <a:rPr lang="en-US" dirty="0"/>
+              <a:t>Results at Re=100, 400, 800</a:t>
+            </a:r>
+          </a:p>
+        </p:txBody>
+      </p:sp>
+      <p:sp>
+        <p:nvSpPr>
+          <p:cNvPr id="3" name="Content Placeholder 2">
+            <a:extLst>
+              <a:ext uri="{FF2B5EF4-FFF2-40B4-BE49-F238E27FC236}">
+                <a16:creationId xmlns:a16="http://schemas.microsoft.com/office/drawing/2014/main" id="{885C0D54-99DD-E31E-26DB-A88D993E79D8}"/>
+              </a:ext>
+            </a:extLst>
+          </p:cNvPr>
+          <p:cNvSpPr>
+            <a:spLocks noGrp="1"/>
+          </p:cNvSpPr>
+          <p:nvPr>
+            <p:ph idx="1"/>
+          </p:nvPr>
+        </p:nvSpPr>
+        <p:spPr/>
+        <p:txBody>
+          <a:bodyPr/>
+          <a:lstStyle/>
+          <a:p>
+            <a:endParaRPr lang="en-US" dirty="0"/>
+          </a:p>
+        </p:txBody>
+      </p:sp>
+    </p:spTree>
+    <p:extLst>
+      <p:ext uri="{BB962C8B-B14F-4D97-AF65-F5344CB8AC3E}">
+        <p14:creationId xmlns:p14="http://schemas.microsoft.com/office/powerpoint/2010/main" val="1095544334"/>
+      </p:ext>
+    </p:extLst>
+  </p:cSld>
+  <p:clrMapOvr>
+    <a:masterClrMapping/>
+  </p:clrMapOvr>
+</p:sld>
+</file>
+
+<file path=ppt/slides/slide11.xml><?xml version="1.0" encoding="utf-8"?>
+<p:sld xmlns:a="http://schemas.openxmlformats.org/drawingml/2006/main" xmlns:r="http://schemas.openxmlformats.org/officeDocument/2006/relationships" xmlns:p="http://schemas.openxmlformats.org/presentationml/2006/main">
+  <p:cSld>
+    <p:spTree>
+      <p:nvGrpSpPr>
+        <p:cNvPr id="1" name=""/>
+        <p:cNvGrpSpPr/>
+        <p:nvPr/>
+      </p:nvGrpSpPr>
+      <p:grpSpPr>
+        <a:xfrm>
+          <a:off x="0" y="0"/>
+          <a:ext cx="0" cy="0"/>
+          <a:chOff x="0" y="0"/>
+          <a:chExt cx="0" cy="0"/>
+        </a:xfrm>
+      </p:grpSpPr>
+      <p:sp>
+        <p:nvSpPr>
+          <p:cNvPr id="2" name="Title 1">
+            <a:extLst>
+              <a:ext uri="{FF2B5EF4-FFF2-40B4-BE49-F238E27FC236}">
+                <a16:creationId xmlns:a16="http://schemas.microsoft.com/office/drawing/2014/main" id="{FB2E32BB-25E9-27ED-B610-6A5E47A250EA}"/>
+              </a:ext>
+            </a:extLst>
+          </p:cNvPr>
+          <p:cNvSpPr>
+            <a:spLocks noGrp="1"/>
+          </p:cNvSpPr>
+          <p:nvPr>
+            <p:ph type="title"/>
+          </p:nvPr>
+        </p:nvSpPr>
+        <p:spPr/>
+        <p:txBody>
+          <a:bodyPr/>
+          <a:lstStyle/>
+          <a:p>
+            <a:r>
+              <a:rPr lang="en-US" dirty="0"/>
+              <a:t>Strengths and Limitations</a:t>
+            </a:r>
+          </a:p>
+        </p:txBody>
+      </p:sp>
+      <p:sp>
+        <p:nvSpPr>
+          <p:cNvPr id="3" name="Content Placeholder 2">
+            <a:extLst>
+              <a:ext uri="{FF2B5EF4-FFF2-40B4-BE49-F238E27FC236}">
+                <a16:creationId xmlns:a16="http://schemas.microsoft.com/office/drawing/2014/main" id="{17574145-5798-88A0-0DA9-018F8901AD84}"/>
+              </a:ext>
+            </a:extLst>
+          </p:cNvPr>
+          <p:cNvSpPr>
+            <a:spLocks noGrp="1"/>
+          </p:cNvSpPr>
+          <p:nvPr>
+            <p:ph idx="1"/>
+          </p:nvPr>
+        </p:nvSpPr>
+        <p:spPr/>
+        <p:txBody>
+          <a:bodyPr/>
+          <a:lstStyle/>
+          <a:p>
+            <a:endParaRPr lang="en-US"/>
+          </a:p>
+        </p:txBody>
+      </p:sp>
+    </p:spTree>
+    <p:extLst>
+      <p:ext uri="{BB962C8B-B14F-4D97-AF65-F5344CB8AC3E}">
+        <p14:creationId xmlns:p14="http://schemas.microsoft.com/office/powerpoint/2010/main" val="505740524"/>
+      </p:ext>
+    </p:extLst>
+  </p:cSld>
+  <p:clrMapOvr>
+    <a:masterClrMapping/>
+  </p:clrMapOvr>
+</p:sld>
+</file>
+
+<file path=ppt/slides/slide12.xml><?xml version="1.0" encoding="utf-8"?>
+<p:sld xmlns:a="http://schemas.openxmlformats.org/drawingml/2006/main" xmlns:r="http://schemas.openxmlformats.org/officeDocument/2006/relationships" xmlns:p="http://schemas.openxmlformats.org/presentationml/2006/main">
+  <p:cSld>
+    <p:spTree>
+      <p:nvGrpSpPr>
+        <p:cNvPr id="1" name=""/>
+        <p:cNvGrpSpPr/>
+        <p:nvPr/>
+      </p:nvGrpSpPr>
+      <p:grpSpPr>
+        <a:xfrm>
+          <a:off x="0" y="0"/>
+          <a:ext cx="0" cy="0"/>
+          <a:chOff x="0" y="0"/>
+          <a:chExt cx="0" cy="0"/>
+        </a:xfrm>
+      </p:grpSpPr>
+      <p:sp>
+        <p:nvSpPr>
+          <p:cNvPr id="2" name="Title 1">
+            <a:extLst>
+              <a:ext uri="{FF2B5EF4-FFF2-40B4-BE49-F238E27FC236}">
+                <a16:creationId xmlns:a16="http://schemas.microsoft.com/office/drawing/2014/main" id="{028621CC-814A-D7A9-4BBC-27FE0D235955}"/>
+              </a:ext>
+            </a:extLst>
+          </p:cNvPr>
+          <p:cNvSpPr>
+            <a:spLocks noGrp="1"/>
+          </p:cNvSpPr>
+          <p:nvPr>
+            <p:ph type="title"/>
+          </p:nvPr>
+        </p:nvSpPr>
+        <p:spPr/>
+        <p:txBody>
+          <a:bodyPr/>
+          <a:lstStyle/>
+          <a:p>
+            <a:r>
+              <a:rPr lang="en-US" dirty="0"/>
+              <a:t>Where PINNs Have the Edge?</a:t>
+            </a:r>
+          </a:p>
+        </p:txBody>
+      </p:sp>
+      <p:sp>
+        <p:nvSpPr>
+          <p:cNvPr id="3" name="Content Placeholder 2">
+            <a:extLst>
+              <a:ext uri="{FF2B5EF4-FFF2-40B4-BE49-F238E27FC236}">
+                <a16:creationId xmlns:a16="http://schemas.microsoft.com/office/drawing/2014/main" id="{D76CBFE0-BFB3-7819-271F-24A0845F1D80}"/>
+              </a:ext>
+            </a:extLst>
+          </p:cNvPr>
+          <p:cNvSpPr>
+            <a:spLocks noGrp="1"/>
+          </p:cNvSpPr>
+          <p:nvPr>
+            <p:ph idx="1"/>
+          </p:nvPr>
+        </p:nvSpPr>
+        <p:spPr/>
+        <p:txBody>
+          <a:bodyPr/>
+          <a:lstStyle/>
+          <a:p>
+            <a:endParaRPr lang="en-US"/>
+          </a:p>
+        </p:txBody>
+      </p:sp>
+    </p:spTree>
+    <p:extLst>
+      <p:ext uri="{BB962C8B-B14F-4D97-AF65-F5344CB8AC3E}">
+        <p14:creationId xmlns:p14="http://schemas.microsoft.com/office/powerpoint/2010/main" val="1861428453"/>
+      </p:ext>
+    </p:extLst>
+  </p:cSld>
+  <p:clrMapOvr>
+    <a:masterClrMapping/>
+  </p:clrMapOvr>
+</p:sld>
+</file>
+
+<file path=ppt/slides/slide13.xml><?xml version="1.0" encoding="utf-8"?>
+<p:sld xmlns:a="http://schemas.openxmlformats.org/drawingml/2006/main" xmlns:r="http://schemas.openxmlformats.org/officeDocument/2006/relationships" xmlns:p="http://schemas.openxmlformats.org/presentationml/2006/main">
+  <p:cSld>
+    <p:spTree>
+      <p:nvGrpSpPr>
+        <p:cNvPr id="1" name=""/>
+        <p:cNvGrpSpPr/>
+        <p:nvPr/>
+      </p:nvGrpSpPr>
+      <p:grpSpPr>
+        <a:xfrm>
+          <a:off x="0" y="0"/>
+          <a:ext cx="0" cy="0"/>
+          <a:chOff x="0" y="0"/>
+          <a:chExt cx="0" cy="0"/>
+        </a:xfrm>
+      </p:grpSpPr>
+      <p:sp>
+        <p:nvSpPr>
+          <p:cNvPr id="2" name="Title 1">
+            <a:extLst>
+              <a:ext uri="{FF2B5EF4-FFF2-40B4-BE49-F238E27FC236}">
+                <a16:creationId xmlns:a16="http://schemas.microsoft.com/office/drawing/2014/main" id="{94E9AA2D-D8BC-9FBA-568C-9089539EAC82}"/>
+              </a:ext>
+            </a:extLst>
+          </p:cNvPr>
+          <p:cNvSpPr>
+            <a:spLocks noGrp="1"/>
+          </p:cNvSpPr>
+          <p:nvPr>
+            <p:ph type="title"/>
+          </p:nvPr>
+        </p:nvSpPr>
+        <p:spPr/>
+        <p:txBody>
+          <a:bodyPr/>
+          <a:lstStyle/>
+          <a:p>
+            <a:r>
+              <a:rPr lang="en-US" dirty="0"/>
+              <a:t>Collaboration Results</a:t>
+            </a:r>
+          </a:p>
+        </p:txBody>
+      </p:sp>
+      <p:sp>
+        <p:nvSpPr>
+          <p:cNvPr id="3" name="Content Placeholder 2">
+            <a:extLst>
+              <a:ext uri="{FF2B5EF4-FFF2-40B4-BE49-F238E27FC236}">
+                <a16:creationId xmlns:a16="http://schemas.microsoft.com/office/drawing/2014/main" id="{06747A52-6C3E-D967-E643-A05597C6FEC8}"/>
+              </a:ext>
+            </a:extLst>
+          </p:cNvPr>
+          <p:cNvSpPr>
+            <a:spLocks noGrp="1"/>
+          </p:cNvSpPr>
+          <p:nvPr>
+            <p:ph idx="1"/>
+          </p:nvPr>
+        </p:nvSpPr>
+        <p:spPr/>
+        <p:txBody>
+          <a:bodyPr/>
+          <a:lstStyle/>
+          <a:p>
+            <a:endParaRPr lang="en-US"/>
+          </a:p>
+        </p:txBody>
+      </p:sp>
+    </p:spTree>
+    <p:extLst>
+      <p:ext uri="{BB962C8B-B14F-4D97-AF65-F5344CB8AC3E}">
+        <p14:creationId xmlns:p14="http://schemas.microsoft.com/office/powerpoint/2010/main" val="120589493"/>
+      </p:ext>
+    </p:extLst>
+  </p:cSld>
+  <p:clrMapOvr>
+    <a:masterClrMapping/>
+  </p:clrMapOvr>
+</p:sld>
+</file>
+
 <file path=ppt/slides/slide2.xml><?xml version="1.0" encoding="utf-8"?>
+<p:sld xmlns:a="http://schemas.openxmlformats.org/drawingml/2006/main" xmlns:r="http://schemas.openxmlformats.org/officeDocument/2006/relationships" xmlns:p="http://schemas.openxmlformats.org/presentationml/2006/main">
+  <p:cSld>
+    <p:spTree>
+      <p:nvGrpSpPr>
+        <p:cNvPr id="1" name=""/>
+        <p:cNvGrpSpPr/>
+        <p:nvPr/>
+      </p:nvGrpSpPr>
+      <p:grpSpPr>
+        <a:xfrm>
+          <a:off x="0" y="0"/>
+          <a:ext cx="0" cy="0"/>
+          <a:chOff x="0" y="0"/>
+          <a:chExt cx="0" cy="0"/>
+        </a:xfrm>
+      </p:grpSpPr>
+      <p:sp>
+        <p:nvSpPr>
+          <p:cNvPr id="2" name="Title 1">
+            <a:extLst>
+              <a:ext uri="{FF2B5EF4-FFF2-40B4-BE49-F238E27FC236}">
+                <a16:creationId xmlns:a16="http://schemas.microsoft.com/office/drawing/2014/main" id="{48FFA5AD-57F9-048D-4E4C-6A7F8C59FB06}"/>
+              </a:ext>
+            </a:extLst>
+          </p:cNvPr>
+          <p:cNvSpPr>
+            <a:spLocks noGrp="1"/>
+          </p:cNvSpPr>
+          <p:nvPr>
+            <p:ph type="title"/>
+          </p:nvPr>
+        </p:nvSpPr>
+        <p:spPr/>
+        <p:txBody>
+          <a:bodyPr/>
+          <a:lstStyle/>
+          <a:p>
+            <a:r>
+              <a:rPr lang="en-US" dirty="0"/>
+              <a:t>Governing Equations</a:t>
+            </a:r>
+          </a:p>
+        </p:txBody>
+      </p:sp>
+      <mc:AlternateContent xmlns:mc="http://schemas.openxmlformats.org/markup-compatibility/2006">
+        <mc:Choice xmlns:a14="http://schemas.microsoft.com/office/drawing/2010/main" Requires="a14">
+          <p:sp>
+            <p:nvSpPr>
+              <p:cNvPr id="3" name="Content Placeholder 2">
+                <a:extLst>
+                  <a:ext uri="{FF2B5EF4-FFF2-40B4-BE49-F238E27FC236}">
+                    <a16:creationId xmlns:a16="http://schemas.microsoft.com/office/drawing/2014/main" id="{8F1F6078-B32A-E9E8-4975-AF0B0A992896}"/>
+                  </a:ext>
+                </a:extLst>
+              </p:cNvPr>
+              <p:cNvSpPr>
+                <a:spLocks noGrp="1"/>
+              </p:cNvSpPr>
+              <p:nvPr>
+                <p:ph idx="1"/>
+              </p:nvPr>
+            </p:nvSpPr>
+            <p:spPr/>
+            <p:txBody>
+              <a:bodyPr/>
+              <a:lstStyle/>
+              <a:p>
+                <a:r>
+                  <a:rPr lang="en-US" b="1" u="sng" dirty="0"/>
+                  <a:t>Incompressible Navier Stokes equation:</a:t>
+                </a:r>
+              </a:p>
+              <a:p>
+                <a:pPr marL="742950" lvl="1" indent="-285750"/>
+                <a:r>
+                  <a:rPr lang="en-US" dirty="0" err="1"/>
+                  <a:t>Momemtum</a:t>
+                </a:r>
+                <a:r>
+                  <a:rPr lang="en-US" dirty="0"/>
+                  <a:t> equation:</a:t>
+                </a:r>
+              </a:p>
+              <a:p>
+                <a:pPr marL="1200150" lvl="2" indent="-285750"/>
+                <a14:m>
+                  <m:oMath xmlns:m="http://schemas.openxmlformats.org/officeDocument/2006/math">
+                    <m:r>
+                      <a:rPr lang="nb-NO" i="1">
+                        <a:latin typeface="Cambria Math" panose="02040503050406030204" pitchFamily="18" charset="0"/>
+                      </a:rPr>
+                      <m:t>𝜌</m:t>
+                    </m:r>
+                    <m:d>
+                      <m:dPr>
+                        <m:ctrlPr>
+                          <a:rPr lang="nb-NO" i="1">
+                            <a:latin typeface="Cambria Math" panose="02040503050406030204" pitchFamily="18" charset="0"/>
+                          </a:rPr>
+                        </m:ctrlPr>
+                      </m:dPr>
+                      <m:e>
+                        <m:f>
+                          <m:fPr>
+                            <m:ctrlPr>
+                              <a:rPr lang="nb-NO" i="1">
+                                <a:latin typeface="Cambria Math" panose="02040503050406030204" pitchFamily="18" charset="0"/>
+                              </a:rPr>
+                            </m:ctrlPr>
+                          </m:fPr>
+                          <m:num>
+                            <m:r>
+                              <a:rPr lang="nb-NO" i="1">
+                                <a:latin typeface="Cambria Math" panose="02040503050406030204" pitchFamily="18" charset="0"/>
+                              </a:rPr>
+                              <m:t>𝜕</m:t>
+                            </m:r>
+                            <m:r>
+                              <a:rPr lang="nb-NO" i="1">
+                                <a:latin typeface="Cambria Math" panose="02040503050406030204" pitchFamily="18" charset="0"/>
+                              </a:rPr>
+                              <m:t>𝐮</m:t>
+                            </m:r>
+                          </m:num>
+                          <m:den>
+                            <m:r>
+                              <a:rPr lang="nb-NO" i="1">
+                                <a:latin typeface="Cambria Math" panose="02040503050406030204" pitchFamily="18" charset="0"/>
+                              </a:rPr>
+                              <m:t>𝜕</m:t>
+                            </m:r>
+                            <m:r>
+                              <a:rPr lang="nb-NO" i="1">
+                                <a:latin typeface="Cambria Math" panose="02040503050406030204" pitchFamily="18" charset="0"/>
+                              </a:rPr>
+                              <m:t>𝑡</m:t>
+                            </m:r>
+                          </m:den>
+                        </m:f>
+                        <m:r>
+                          <a:rPr lang="nb-NO" i="1">
+                            <a:latin typeface="Cambria Math" panose="02040503050406030204" pitchFamily="18" charset="0"/>
+                          </a:rPr>
+                          <m:t>+</m:t>
+                        </m:r>
+                        <m:r>
+                          <a:rPr lang="nb-NO" i="1">
+                            <a:latin typeface="Cambria Math" panose="02040503050406030204" pitchFamily="18" charset="0"/>
+                          </a:rPr>
+                          <m:t>𝐮</m:t>
+                        </m:r>
+                        <m:r>
+                          <a:rPr lang="nb-NO" i="1">
+                            <a:latin typeface="Cambria Math" panose="02040503050406030204" pitchFamily="18" charset="0"/>
+                          </a:rPr>
+                          <m:t>⋅</m:t>
+                        </m:r>
+                        <m:r>
+                          <m:rPr>
+                            <m:sty m:val="p"/>
+                          </m:rPr>
+                          <a:rPr lang="nb-NO">
+                            <a:latin typeface="Cambria Math" panose="02040503050406030204" pitchFamily="18" charset="0"/>
+                          </a:rPr>
+                          <m:t>∇</m:t>
+                        </m:r>
+                        <m:r>
+                          <a:rPr lang="nb-NO" i="1">
+                            <a:latin typeface="Cambria Math" panose="02040503050406030204" pitchFamily="18" charset="0"/>
+                          </a:rPr>
+                          <m:t>𝐮</m:t>
+                        </m:r>
+                      </m:e>
+                    </m:d>
+                    <m:r>
+                      <a:rPr lang="nb-NO" i="1">
+                        <a:latin typeface="Cambria Math" panose="02040503050406030204" pitchFamily="18" charset="0"/>
+                      </a:rPr>
+                      <m:t>=−</m:t>
+                    </m:r>
+                    <m:r>
+                      <m:rPr>
+                        <m:sty m:val="p"/>
+                      </m:rPr>
+                      <a:rPr lang="nb-NO">
+                        <a:latin typeface="Cambria Math" panose="02040503050406030204" pitchFamily="18" charset="0"/>
+                      </a:rPr>
+                      <m:t>∇</m:t>
+                    </m:r>
+                    <m:r>
+                      <m:rPr>
+                        <m:sty m:val="p"/>
+                      </m:rPr>
+                      <a:rPr lang="nb-NO" i="1">
+                        <a:latin typeface="Cambria Math" panose="02040503050406030204" pitchFamily="18" charset="0"/>
+                      </a:rPr>
+                      <m:t>p</m:t>
+                    </m:r>
+                    <m:r>
+                      <a:rPr lang="nb-NO" i="1">
+                        <a:latin typeface="Cambria Math" panose="02040503050406030204" pitchFamily="18" charset="0"/>
+                      </a:rPr>
+                      <m:t>+</m:t>
+                    </m:r>
+                    <m:r>
+                      <a:rPr lang="nb-NO" i="1">
+                        <a:latin typeface="Cambria Math" panose="02040503050406030204" pitchFamily="18" charset="0"/>
+                      </a:rPr>
+                      <m:t>𝜇</m:t>
+                    </m:r>
+                    <m:sSup>
+                      <m:sSupPr>
+                        <m:ctrlPr>
+                          <a:rPr lang="nb-NO" i="1">
+                            <a:latin typeface="Cambria Math" panose="02040503050406030204" pitchFamily="18" charset="0"/>
+                          </a:rPr>
+                        </m:ctrlPr>
+                      </m:sSupPr>
+                      <m:e>
+                        <m:r>
+                          <m:rPr>
+                            <m:sty m:val="p"/>
+                          </m:rPr>
+                          <a:rPr lang="nb-NO">
+                            <a:latin typeface="Cambria Math" panose="02040503050406030204" pitchFamily="18" charset="0"/>
+                          </a:rPr>
+                          <m:t>∇</m:t>
+                        </m:r>
+                      </m:e>
+                      <m:sup>
+                        <m:r>
+                          <a:rPr lang="nb-NO" i="1">
+                            <a:latin typeface="Cambria Math" panose="02040503050406030204" pitchFamily="18" charset="0"/>
+                          </a:rPr>
+                          <m:t>2</m:t>
+                        </m:r>
+                      </m:sup>
+                    </m:sSup>
+                    <m:r>
+                      <a:rPr lang="nb-NO" i="1">
+                        <a:latin typeface="Cambria Math" panose="02040503050406030204" pitchFamily="18" charset="0"/>
+                      </a:rPr>
+                      <m:t>𝐮</m:t>
+                    </m:r>
+                  </m:oMath>
+                </a14:m>
+                <a:endParaRPr lang="en-US" dirty="0"/>
+              </a:p>
+              <a:p>
+                <a:pPr marL="742950" lvl="1" indent="-285750"/>
+                <a:r>
+                  <a:rPr lang="nb-NO" dirty="0" err="1">
+                    <a:latin typeface="Cambria Math" panose="02040503050406030204" pitchFamily="18" charset="0"/>
+                  </a:rPr>
+                  <a:t>Continuity</a:t>
+                </a:r>
+                <a:r>
+                  <a:rPr lang="nb-NO" dirty="0">
+                    <a:latin typeface="Cambria Math" panose="02040503050406030204" pitchFamily="18" charset="0"/>
+                  </a:rPr>
+                  <a:t> </a:t>
+                </a:r>
+                <a:r>
+                  <a:rPr lang="nb-NO" dirty="0" err="1">
+                    <a:latin typeface="Cambria Math" panose="02040503050406030204" pitchFamily="18" charset="0"/>
+                  </a:rPr>
+                  <a:t>equation</a:t>
+                </a:r>
+                <a:r>
+                  <a:rPr lang="nb-NO" dirty="0">
+                    <a:latin typeface="Cambria Math" panose="02040503050406030204" pitchFamily="18" charset="0"/>
+                  </a:rPr>
+                  <a:t>:</a:t>
+                </a:r>
+              </a:p>
+              <a:p>
+                <a:pPr marL="1200150" lvl="2" indent="-285750"/>
+                <a14:m>
+                  <m:oMath xmlns:m="http://schemas.openxmlformats.org/officeDocument/2006/math">
+                    <m:r>
+                      <m:rPr>
+                        <m:sty m:val="p"/>
+                      </m:rPr>
+                      <a:rPr lang="nb-NO">
+                        <a:latin typeface="Cambria Math" panose="02040503050406030204" pitchFamily="18" charset="0"/>
+                      </a:rPr>
+                      <m:t>∇</m:t>
+                    </m:r>
+                    <m:r>
+                      <a:rPr lang="nb-NO" i="1">
+                        <a:latin typeface="Cambria Math" panose="02040503050406030204" pitchFamily="18" charset="0"/>
+                      </a:rPr>
+                      <m:t>⋅</m:t>
+                    </m:r>
+                    <m:r>
+                      <a:rPr lang="nb-NO" i="1">
+                        <a:latin typeface="Cambria Math" panose="02040503050406030204" pitchFamily="18" charset="0"/>
+                      </a:rPr>
+                      <m:t>𝐮</m:t>
+                    </m:r>
+                    <m:r>
+                      <a:rPr lang="nb-NO" i="1">
+                        <a:latin typeface="Cambria Math" panose="02040503050406030204" pitchFamily="18" charset="0"/>
+                      </a:rPr>
+                      <m:t>=0</m:t>
+                    </m:r>
+                  </m:oMath>
+                </a14:m>
+                <a:endParaRPr lang="en-US" dirty="0"/>
+              </a:p>
+            </p:txBody>
+          </p:sp>
+        </mc:Choice>
+        <mc:Fallback>
+          <p:sp>
+            <p:nvSpPr>
+              <p:cNvPr id="3" name="Content Placeholder 2">
+                <a:extLst>
+                  <a:ext uri="{FF2B5EF4-FFF2-40B4-BE49-F238E27FC236}">
+                    <a16:creationId xmlns:a16="http://schemas.microsoft.com/office/drawing/2014/main" id="{8F1F6078-B32A-E9E8-4975-AF0B0A992896}"/>
+                  </a:ext>
+                </a:extLst>
+              </p:cNvPr>
+              <p:cNvSpPr>
+                <a:spLocks noGrp="1" noRot="1" noChangeAspect="1" noMove="1" noResize="1" noEditPoints="1" noAdjustHandles="1" noChangeArrowheads="1" noChangeShapeType="1" noTextEdit="1"/>
+              </p:cNvSpPr>
+              <p:nvPr>
+                <p:ph idx="1"/>
+              </p:nvPr>
+            </p:nvSpPr>
+            <p:spPr>
+              <a:blipFill>
+                <a:blip r:embed="rId2"/>
+                <a:stretch>
+                  <a:fillRect l="-233"/>
+                </a:stretch>
+              </a:blipFill>
+            </p:spPr>
+            <p:txBody>
+              <a:bodyPr/>
+              <a:lstStyle/>
+              <a:p>
+                <a:r>
+                  <a:rPr lang="en-US">
+                    <a:noFill/>
+                  </a:rPr>
+                  <a:t> </a:t>
+                </a:r>
+              </a:p>
+            </p:txBody>
+          </p:sp>
+        </mc:Fallback>
+      </mc:AlternateContent>
+    </p:spTree>
+    <p:extLst>
+      <p:ext uri="{BB962C8B-B14F-4D97-AF65-F5344CB8AC3E}">
+        <p14:creationId xmlns:p14="http://schemas.microsoft.com/office/powerpoint/2010/main" val="3069239637"/>
+      </p:ext>
+    </p:extLst>
+  </p:cSld>
+  <p:clrMapOvr>
+    <a:masterClrMapping/>
+  </p:clrMapOvr>
+</p:sld>
+</file>
+
+<file path=ppt/slides/slide3.xml><?xml version="1.0" encoding="utf-8"?>
 <p:sld xmlns:a="http://schemas.openxmlformats.org/drawingml/2006/main" xmlns:r="http://schemas.openxmlformats.org/officeDocument/2006/relationships" xmlns:p="http://schemas.openxmlformats.org/presentationml/2006/main">
   <p:cSld>
     <p:spTree>
@@ -4630,349 +5333,6 @@
           </p:sp>
         </mc:Fallback>
       </mc:AlternateContent>
-      <mc:AlternateContent xmlns:mc="http://schemas.openxmlformats.org/markup-compatibility/2006">
-        <mc:Choice xmlns:a14="http://schemas.microsoft.com/office/drawing/2010/main" Requires="a14">
-          <p:sp>
-            <p:nvSpPr>
-              <p:cNvPr id="4" name="TextBox 3">
-                <a:extLst>
-                  <a:ext uri="{FF2B5EF4-FFF2-40B4-BE49-F238E27FC236}">
-                    <a16:creationId xmlns:a16="http://schemas.microsoft.com/office/drawing/2014/main" id="{139D16DC-7C6B-3BBB-4B58-F5254E726C74}"/>
-                  </a:ext>
-                </a:extLst>
-              </p:cNvPr>
-              <p:cNvSpPr txBox="1"/>
-              <p:nvPr/>
-            </p:nvSpPr>
-            <p:spPr>
-              <a:xfrm>
-                <a:off x="6085543" y="1349754"/>
-                <a:ext cx="4921686" cy="1891865"/>
-              </a:xfrm>
-              <a:prstGeom prst="rect">
-                <a:avLst/>
-              </a:prstGeom>
-              <a:noFill/>
-            </p:spPr>
-            <p:txBody>
-              <a:bodyPr wrap="square" rtlCol="0">
-                <a:spAutoFit/>
-              </a:bodyPr>
-              <a:lstStyle/>
-              <a:p>
-                <a:r>
-                  <a:rPr lang="en-US" b="1" u="sng" dirty="0"/>
-                  <a:t>Incompressible Navier Stokes equation:</a:t>
-                </a:r>
-              </a:p>
-              <a:p>
-                <a:pPr marL="742950" lvl="1" indent="-285750">
-                  <a:buFont typeface="Arial" panose="020B0604020202020204" pitchFamily="34" charset="0"/>
-                  <a:buChar char="•"/>
-                </a:pPr>
-                <a:r>
-                  <a:rPr lang="en-US" dirty="0" err="1"/>
-                  <a:t>Momemtum</a:t>
-                </a:r>
-                <a:r>
-                  <a:rPr lang="en-US" dirty="0"/>
-                  <a:t> equation:</a:t>
-                </a:r>
-              </a:p>
-              <a:p>
-                <a:pPr marL="1200150" lvl="2" indent="-285750">
-                  <a:buFont typeface="Arial" panose="020B0604020202020204" pitchFamily="34" charset="0"/>
-                  <a:buChar char="•"/>
-                </a:pPr>
-                <a14:m>
-                  <m:oMath xmlns:m="http://schemas.openxmlformats.org/officeDocument/2006/math">
-                    <m:r>
-                      <a:rPr lang="nb-NO" b="0" i="1" smtClean="0">
-                        <a:latin typeface="Cambria Math" panose="02040503050406030204" pitchFamily="18" charset="0"/>
-                      </a:rPr>
-                      <m:t>𝜌</m:t>
-                    </m:r>
-                    <m:d>
-                      <m:dPr>
-                        <m:ctrlPr>
-                          <a:rPr lang="nb-NO" b="0" i="1" smtClean="0">
-                            <a:latin typeface="Cambria Math" panose="02040503050406030204" pitchFamily="18" charset="0"/>
-                          </a:rPr>
-                        </m:ctrlPr>
-                      </m:dPr>
-                      <m:e>
-                        <m:f>
-                          <m:fPr>
-                            <m:ctrlPr>
-                              <a:rPr lang="nb-NO" b="0" i="1" smtClean="0">
-                                <a:latin typeface="Cambria Math" panose="02040503050406030204" pitchFamily="18" charset="0"/>
-                              </a:rPr>
-                            </m:ctrlPr>
-                          </m:fPr>
-                          <m:num>
-                            <m:r>
-                              <a:rPr lang="nb-NO" b="0" i="1" smtClean="0">
-                                <a:latin typeface="Cambria Math" panose="02040503050406030204" pitchFamily="18" charset="0"/>
-                              </a:rPr>
-                              <m:t>𝜕</m:t>
-                            </m:r>
-                            <m:r>
-                              <a:rPr lang="nb-NO" b="0" i="1" smtClean="0">
-                                <a:latin typeface="Cambria Math" panose="02040503050406030204" pitchFamily="18" charset="0"/>
-                              </a:rPr>
-                              <m:t>𝐮</m:t>
-                            </m:r>
-                          </m:num>
-                          <m:den>
-                            <m:r>
-                              <a:rPr lang="nb-NO" b="0" i="1" smtClean="0">
-                                <a:latin typeface="Cambria Math" panose="02040503050406030204" pitchFamily="18" charset="0"/>
-                              </a:rPr>
-                              <m:t>𝜕</m:t>
-                            </m:r>
-                            <m:r>
-                              <a:rPr lang="nb-NO" b="0" i="1" smtClean="0">
-                                <a:latin typeface="Cambria Math" panose="02040503050406030204" pitchFamily="18" charset="0"/>
-                              </a:rPr>
-                              <m:t>𝑡</m:t>
-                            </m:r>
-                          </m:den>
-                        </m:f>
-                        <m:r>
-                          <a:rPr lang="nb-NO" b="0" i="1" smtClean="0">
-                            <a:latin typeface="Cambria Math" panose="02040503050406030204" pitchFamily="18" charset="0"/>
-                          </a:rPr>
-                          <m:t>+</m:t>
-                        </m:r>
-                        <m:r>
-                          <a:rPr lang="nb-NO" b="0" i="1" smtClean="0">
-                            <a:latin typeface="Cambria Math" panose="02040503050406030204" pitchFamily="18" charset="0"/>
-                          </a:rPr>
-                          <m:t>𝐮</m:t>
-                        </m:r>
-                        <m:r>
-                          <a:rPr lang="nb-NO" b="0" i="1" smtClean="0">
-                            <a:latin typeface="Cambria Math" panose="02040503050406030204" pitchFamily="18" charset="0"/>
-                          </a:rPr>
-                          <m:t>⋅</m:t>
-                        </m:r>
-                        <m:r>
-                          <m:rPr>
-                            <m:sty m:val="p"/>
-                          </m:rPr>
-                          <a:rPr lang="nb-NO" b="0" i="0" smtClean="0">
-                            <a:latin typeface="Cambria Math" panose="02040503050406030204" pitchFamily="18" charset="0"/>
-                          </a:rPr>
-                          <m:t>∇</m:t>
-                        </m:r>
-                        <m:r>
-                          <a:rPr lang="nb-NO" b="0" i="1" smtClean="0">
-                            <a:latin typeface="Cambria Math" panose="02040503050406030204" pitchFamily="18" charset="0"/>
-                          </a:rPr>
-                          <m:t>𝐮</m:t>
-                        </m:r>
-                      </m:e>
-                    </m:d>
-                    <m:r>
-                      <a:rPr lang="nb-NO" b="0" i="1" smtClean="0">
-                        <a:latin typeface="Cambria Math" panose="02040503050406030204" pitchFamily="18" charset="0"/>
-                      </a:rPr>
-                      <m:t>=−</m:t>
-                    </m:r>
-                    <m:r>
-                      <m:rPr>
-                        <m:sty m:val="p"/>
-                      </m:rPr>
-                      <a:rPr lang="nb-NO" b="0" i="0" smtClean="0">
-                        <a:latin typeface="Cambria Math" panose="02040503050406030204" pitchFamily="18" charset="0"/>
-                      </a:rPr>
-                      <m:t>∇</m:t>
-                    </m:r>
-                    <m:r>
-                      <m:rPr>
-                        <m:sty m:val="p"/>
-                      </m:rPr>
-                      <a:rPr lang="nb-NO" b="0" i="1" smtClean="0">
-                        <a:latin typeface="Cambria Math" panose="02040503050406030204" pitchFamily="18" charset="0"/>
-                      </a:rPr>
-                      <m:t>p</m:t>
-                    </m:r>
-                    <m:r>
-                      <a:rPr lang="nb-NO" b="0" i="1" smtClean="0">
-                        <a:latin typeface="Cambria Math" panose="02040503050406030204" pitchFamily="18" charset="0"/>
-                      </a:rPr>
-                      <m:t>+</m:t>
-                    </m:r>
-                    <m:r>
-                      <a:rPr lang="nb-NO" b="0" i="1" smtClean="0">
-                        <a:latin typeface="Cambria Math" panose="02040503050406030204" pitchFamily="18" charset="0"/>
-                      </a:rPr>
-                      <m:t>𝜇</m:t>
-                    </m:r>
-                    <m:sSup>
-                      <m:sSupPr>
-                        <m:ctrlPr>
-                          <a:rPr lang="nb-NO" b="0" i="1" smtClean="0">
-                            <a:latin typeface="Cambria Math" panose="02040503050406030204" pitchFamily="18" charset="0"/>
-                          </a:rPr>
-                        </m:ctrlPr>
-                      </m:sSupPr>
-                      <m:e>
-                        <m:r>
-                          <m:rPr>
-                            <m:sty m:val="p"/>
-                          </m:rPr>
-                          <a:rPr lang="nb-NO" b="0" i="0" smtClean="0">
-                            <a:latin typeface="Cambria Math" panose="02040503050406030204" pitchFamily="18" charset="0"/>
-                          </a:rPr>
-                          <m:t>∇</m:t>
-                        </m:r>
-                      </m:e>
-                      <m:sup>
-                        <m:r>
-                          <a:rPr lang="nb-NO" b="0" i="1" smtClean="0">
-                            <a:latin typeface="Cambria Math" panose="02040503050406030204" pitchFamily="18" charset="0"/>
-                          </a:rPr>
-                          <m:t>2</m:t>
-                        </m:r>
-                      </m:sup>
-                    </m:sSup>
-                    <m:r>
-                      <a:rPr lang="nb-NO" b="0" i="1" smtClean="0">
-                        <a:latin typeface="Cambria Math" panose="02040503050406030204" pitchFamily="18" charset="0"/>
-                      </a:rPr>
-                      <m:t>𝐮</m:t>
-                    </m:r>
-                  </m:oMath>
-                </a14:m>
-                <a:endParaRPr lang="en-US" dirty="0"/>
-              </a:p>
-              <a:p>
-                <a:pPr marL="742950" lvl="1" indent="-285750">
-                  <a:buFont typeface="Arial" panose="020B0604020202020204" pitchFamily="34" charset="0"/>
-                  <a:buChar char="•"/>
-                </a:pPr>
-                <a:r>
-                  <a:rPr lang="nb-NO" b="0" i="0" dirty="0" err="1">
-                    <a:latin typeface="Cambria Math" panose="02040503050406030204" pitchFamily="18" charset="0"/>
-                  </a:rPr>
-                  <a:t>Continuity</a:t>
-                </a:r>
-                <a:r>
-                  <a:rPr lang="nb-NO" b="0" i="0" dirty="0">
-                    <a:latin typeface="Cambria Math" panose="02040503050406030204" pitchFamily="18" charset="0"/>
-                  </a:rPr>
-                  <a:t> </a:t>
-                </a:r>
-                <a:r>
-                  <a:rPr lang="nb-NO" b="0" i="0" dirty="0" err="1">
-                    <a:latin typeface="Cambria Math" panose="02040503050406030204" pitchFamily="18" charset="0"/>
-                  </a:rPr>
-                  <a:t>equation</a:t>
-                </a:r>
-                <a:r>
-                  <a:rPr lang="nb-NO" b="0" i="0" dirty="0">
-                    <a:latin typeface="Cambria Math" panose="02040503050406030204" pitchFamily="18" charset="0"/>
-                  </a:rPr>
-                  <a:t>:</a:t>
-                </a:r>
-              </a:p>
-              <a:p>
-                <a:pPr marL="1200150" lvl="2" indent="-285750">
-                  <a:buFont typeface="Arial" panose="020B0604020202020204" pitchFamily="34" charset="0"/>
-                  <a:buChar char="•"/>
-                </a:pPr>
-                <a14:m>
-                  <m:oMath xmlns:m="http://schemas.openxmlformats.org/officeDocument/2006/math">
-                    <m:r>
-                      <m:rPr>
-                        <m:sty m:val="p"/>
-                      </m:rPr>
-                      <a:rPr lang="nb-NO" b="0" i="0" smtClean="0">
-                        <a:latin typeface="Cambria Math" panose="02040503050406030204" pitchFamily="18" charset="0"/>
-                      </a:rPr>
-                      <m:t>∇</m:t>
-                    </m:r>
-                    <m:r>
-                      <a:rPr lang="nb-NO" b="0" i="1" smtClean="0">
-                        <a:latin typeface="Cambria Math" panose="02040503050406030204" pitchFamily="18" charset="0"/>
-                      </a:rPr>
-                      <m:t>⋅</m:t>
-                    </m:r>
-                    <m:r>
-                      <a:rPr lang="nb-NO" b="0" i="1" smtClean="0">
-                        <a:latin typeface="Cambria Math" panose="02040503050406030204" pitchFamily="18" charset="0"/>
-                      </a:rPr>
-                      <m:t>𝐮</m:t>
-                    </m:r>
-                    <m:r>
-                      <a:rPr lang="nb-NO" b="0" i="1" smtClean="0">
-                        <a:latin typeface="Cambria Math" panose="02040503050406030204" pitchFamily="18" charset="0"/>
-                      </a:rPr>
-                      <m:t>=0</m:t>
-                    </m:r>
-                  </m:oMath>
-                </a14:m>
-                <a:r>
-                  <a:rPr lang="en-US" dirty="0"/>
-                  <a:t>	</a:t>
-                </a:r>
-              </a:p>
-              <a:p>
-                <a:pPr marL="742950" lvl="1" indent="-285750">
-                  <a:buFont typeface="Arial" panose="020B0604020202020204" pitchFamily="34" charset="0"/>
-                  <a:buChar char="•"/>
-                </a:pPr>
-                <a:endParaRPr lang="en-US" dirty="0"/>
-              </a:p>
-            </p:txBody>
-          </p:sp>
-        </mc:Choice>
-        <mc:Fallback>
-          <p:sp>
-            <p:nvSpPr>
-              <p:cNvPr id="4" name="TextBox 3">
-                <a:extLst>
-                  <a:ext uri="{FF2B5EF4-FFF2-40B4-BE49-F238E27FC236}">
-                    <a16:creationId xmlns:a16="http://schemas.microsoft.com/office/drawing/2014/main" id="{139D16DC-7C6B-3BBB-4B58-F5254E726C74}"/>
-                  </a:ext>
-                </a:extLst>
-              </p:cNvPr>
-              <p:cNvSpPr txBox="1">
-                <a:spLocks noRot="1" noChangeAspect="1" noMove="1" noResize="1" noEditPoints="1" noAdjustHandles="1" noChangeArrowheads="1" noChangeShapeType="1" noTextEdit="1"/>
-              </p:cNvSpPr>
-              <p:nvPr/>
-            </p:nvSpPr>
-            <p:spPr>
-              <a:xfrm>
-                <a:off x="6085543" y="1349754"/>
-                <a:ext cx="4921686" cy="1891865"/>
-              </a:xfrm>
-              <a:prstGeom prst="rect">
-                <a:avLst/>
-              </a:prstGeom>
-              <a:blipFill>
-                <a:blip r:embed="rId3"/>
-                <a:stretch>
-                  <a:fillRect l="-1031" t="-1333"/>
-                </a:stretch>
-              </a:blipFill>
-            </p:spPr>
-            <p:txBody>
-              <a:bodyPr/>
-              <a:lstStyle/>
-              <a:p>
-                <a:r>
-                  <a:rPr lang="en-US">
-                    <a:noFill/>
-                  </a:rPr>
-                  <a:t> </a:t>
-                </a:r>
-              </a:p>
-            </p:txBody>
-          </p:sp>
-        </mc:Fallback>
-      </mc:AlternateContent>
       <p:sp>
         <p:nvSpPr>
           <p:cNvPr id="8" name="TextBox 7">
@@ -4987,7 +5347,7 @@
         </p:nvSpPr>
         <p:spPr>
           <a:xfrm>
-            <a:off x="6023428" y="3788229"/>
+            <a:off x="5399313" y="3730752"/>
             <a:ext cx="1681871" cy="369332"/>
           </a:xfrm>
           <a:prstGeom prst="rect">
@@ -5008,111 +5368,45 @@
           </a:p>
         </p:txBody>
       </p:sp>
+      <p:sp>
+        <p:nvSpPr>
+          <p:cNvPr id="9" name="TextBox 8">
+            <a:extLst>
+              <a:ext uri="{FF2B5EF4-FFF2-40B4-BE49-F238E27FC236}">
+                <a16:creationId xmlns:a16="http://schemas.microsoft.com/office/drawing/2014/main" id="{D985A21F-05D6-70D7-2FC3-9BB837CD769E}"/>
+              </a:ext>
+            </a:extLst>
+          </p:cNvPr>
+          <p:cNvSpPr txBox="1"/>
+          <p:nvPr/>
+        </p:nvSpPr>
+        <p:spPr>
+          <a:xfrm>
+            <a:off x="8418443" y="3730752"/>
+            <a:ext cx="3339548" cy="369332"/>
+          </a:xfrm>
+          <a:prstGeom prst="rect">
+            <a:avLst/>
+          </a:prstGeom>
+          <a:noFill/>
+        </p:spPr>
+        <p:txBody>
+          <a:bodyPr wrap="square" rtlCol="0">
+            <a:spAutoFit/>
+          </a:bodyPr>
+          <a:lstStyle/>
+          <a:p>
+            <a:r>
+              <a:rPr lang="en-US" dirty="0"/>
+              <a:t>Inverse problem</a:t>
+            </a:r>
+          </a:p>
+        </p:txBody>
+      </p:sp>
     </p:spTree>
     <p:extLst>
       <p:ext uri="{BB962C8B-B14F-4D97-AF65-F5344CB8AC3E}">
         <p14:creationId xmlns:p14="http://schemas.microsoft.com/office/powerpoint/2010/main" val="2604914428"/>
-      </p:ext>
-    </p:extLst>
-  </p:cSld>
-  <p:clrMapOvr>
-    <a:masterClrMapping/>
-  </p:clrMapOvr>
-</p:sld>
-</file>
-
-<file path=ppt/slides/slide3.xml><?xml version="1.0" encoding="utf-8"?>
-<p:sld xmlns:a="http://schemas.openxmlformats.org/drawingml/2006/main" xmlns:r="http://schemas.openxmlformats.org/officeDocument/2006/relationships" xmlns:p="http://schemas.openxmlformats.org/presentationml/2006/main">
-  <p:cSld>
-    <p:spTree>
-      <p:nvGrpSpPr>
-        <p:cNvPr id="1" name=""/>
-        <p:cNvGrpSpPr/>
-        <p:nvPr/>
-      </p:nvGrpSpPr>
-      <p:grpSpPr>
-        <a:xfrm>
-          <a:off x="0" y="0"/>
-          <a:ext cx="0" cy="0"/>
-          <a:chOff x="0" y="0"/>
-          <a:chExt cx="0" cy="0"/>
-        </a:xfrm>
-      </p:grpSpPr>
-      <p:sp>
-        <p:nvSpPr>
-          <p:cNvPr id="2" name="Title 1">
-            <a:extLst>
-              <a:ext uri="{FF2B5EF4-FFF2-40B4-BE49-F238E27FC236}">
-                <a16:creationId xmlns:a16="http://schemas.microsoft.com/office/drawing/2014/main" id="{1FF187FB-3826-A13A-27DE-1AD08BEE92BE}"/>
-              </a:ext>
-            </a:extLst>
-          </p:cNvPr>
-          <p:cNvSpPr>
-            <a:spLocks noGrp="1"/>
-          </p:cNvSpPr>
-          <p:nvPr>
-            <p:ph type="title"/>
-          </p:nvPr>
-        </p:nvSpPr>
-        <p:spPr/>
-        <p:txBody>
-          <a:bodyPr/>
-          <a:lstStyle/>
-          <a:p>
-            <a:r>
-              <a:rPr lang="en-US" dirty="0"/>
-              <a:t>Solver 1: Finite Volume Method (</a:t>
-            </a:r>
-            <a:r>
-              <a:rPr lang="en-US" dirty="0" err="1"/>
-              <a:t>openFoam</a:t>
-            </a:r>
-            <a:r>
-              <a:rPr lang="en-US" dirty="0"/>
-              <a:t>)</a:t>
-            </a:r>
-          </a:p>
-        </p:txBody>
-      </p:sp>
-      <p:sp>
-        <p:nvSpPr>
-          <p:cNvPr id="3" name="Content Placeholder 2">
-            <a:extLst>
-              <a:ext uri="{FF2B5EF4-FFF2-40B4-BE49-F238E27FC236}">
-                <a16:creationId xmlns:a16="http://schemas.microsoft.com/office/drawing/2014/main" id="{B7736C5A-0001-B896-535C-4B88340099F2}"/>
-              </a:ext>
-            </a:extLst>
-          </p:cNvPr>
-          <p:cNvSpPr>
-            <a:spLocks noGrp="1"/>
-          </p:cNvSpPr>
-          <p:nvPr>
-            <p:ph idx="1"/>
-          </p:nvPr>
-        </p:nvSpPr>
-        <p:spPr/>
-        <p:txBody>
-          <a:bodyPr/>
-          <a:lstStyle/>
-          <a:p>
-            <a:r>
-              <a:rPr lang="en-US" dirty="0"/>
-              <a:t>Uses </a:t>
-            </a:r>
-            <a:r>
-              <a:rPr lang="en-US"/>
-              <a:t>Piso algorithm</a:t>
-            </a:r>
-          </a:p>
-          <a:p>
-            <a:endParaRPr lang="en-US"/>
-          </a:p>
-        </p:txBody>
-      </p:sp>
-    </p:spTree>
-    <p:extLst>
-      <p:ext uri="{BB962C8B-B14F-4D97-AF65-F5344CB8AC3E}">
-        <p14:creationId xmlns:p14="http://schemas.microsoft.com/office/powerpoint/2010/main" val="1463697046"/>
       </p:ext>
     </p:extLst>
   </p:cSld>
@@ -5144,7 +5438,7 @@
           <p:cNvPr id="2" name="Title 1">
             <a:extLst>
               <a:ext uri="{FF2B5EF4-FFF2-40B4-BE49-F238E27FC236}">
-                <a16:creationId xmlns:a16="http://schemas.microsoft.com/office/drawing/2014/main" id="{93D60F15-EB9B-302A-A859-87B8B6C516A4}"/>
+                <a16:creationId xmlns:a16="http://schemas.microsoft.com/office/drawing/2014/main" id="{1FF187FB-3826-A13A-27DE-1AD08BEE92BE}"/>
               </a:ext>
             </a:extLst>
           </p:cNvPr>
@@ -5162,8 +5456,65 @@
           <a:p>
             <a:r>
               <a:rPr lang="en-US" dirty="0"/>
-              <a:t>Solver 2: Physics-Informed Neural Networks</a:t>
-            </a:r>
+              <a:t>Solver 1: </a:t>
+            </a:r>
+            <a:r>
+              <a:rPr lang="en-US" dirty="0" err="1"/>
+              <a:t>OpenFoam</a:t>
+            </a:r>
+            <a:endParaRPr lang="en-US" dirty="0"/>
+          </a:p>
+        </p:txBody>
+      </p:sp>
+      <p:sp>
+        <p:nvSpPr>
+          <p:cNvPr id="9" name="Rectangle 8">
+            <a:extLst>
+              <a:ext uri="{FF2B5EF4-FFF2-40B4-BE49-F238E27FC236}">
+                <a16:creationId xmlns:a16="http://schemas.microsoft.com/office/drawing/2014/main" id="{CA2C8DE6-7EF3-0AEF-CD88-CD8C02BCA828}"/>
+              </a:ext>
+            </a:extLst>
+          </p:cNvPr>
+          <p:cNvSpPr/>
+          <p:nvPr/>
+        </p:nvSpPr>
+        <p:spPr>
+          <a:xfrm>
+            <a:off x="1301069" y="3840479"/>
+            <a:ext cx="10890931" cy="2550382"/>
+          </a:xfrm>
+          <a:prstGeom prst="rect">
+            <a:avLst/>
+          </a:prstGeom>
+          <a:solidFill>
+            <a:schemeClr val="tx2">
+              <a:lumMod val="25000"/>
+              <a:lumOff val="75000"/>
+            </a:schemeClr>
+          </a:solidFill>
+        </p:spPr>
+        <p:style>
+          <a:lnRef idx="2">
+            <a:schemeClr val="accent1">
+              <a:shade val="15000"/>
+            </a:schemeClr>
+          </a:lnRef>
+          <a:fillRef idx="1">
+            <a:schemeClr val="accent1"/>
+          </a:fillRef>
+          <a:effectRef idx="0">
+            <a:schemeClr val="accent1"/>
+          </a:effectRef>
+          <a:fontRef idx="minor">
+            <a:schemeClr val="lt1"/>
+          </a:fontRef>
+        </p:style>
+        <p:txBody>
+          <a:bodyPr rtlCol="0" anchor="ctr"/>
+          <a:lstStyle/>
+          <a:p>
+            <a:pPr algn="ctr"/>
+            <a:endParaRPr lang="en-US" dirty="0"/>
           </a:p>
         </p:txBody>
       </p:sp>
@@ -5172,7 +5523,7 @@
           <p:cNvPr id="3" name="Content Placeholder 2">
             <a:extLst>
               <a:ext uri="{FF2B5EF4-FFF2-40B4-BE49-F238E27FC236}">
-                <a16:creationId xmlns:a16="http://schemas.microsoft.com/office/drawing/2014/main" id="{B9E74C17-3885-BB6C-CBC1-19540CA9777A}"/>
+                <a16:creationId xmlns:a16="http://schemas.microsoft.com/office/drawing/2014/main" id="{B7736C5A-0001-B896-535C-4B88340099F2}"/>
               </a:ext>
             </a:extLst>
           </p:cNvPr>
@@ -5183,19 +5534,363 @@
             <p:ph idx="1"/>
           </p:nvPr>
         </p:nvSpPr>
-        <p:spPr/>
-        <p:txBody>
-          <a:bodyPr/>
-          <a:lstStyle/>
-          <a:p>
+        <p:spPr>
+          <a:xfrm>
+            <a:off x="1301069" y="4434839"/>
+            <a:ext cx="10890929" cy="1886448"/>
+          </a:xfrm>
+        </p:spPr>
+        <p:txBody>
+          <a:bodyPr>
+            <a:normAutofit lnSpcReduction="10000"/>
+          </a:bodyPr>
+          <a:lstStyle/>
+          <a:p>
+            <a:r>
+              <a:rPr lang="en-US" dirty="0"/>
+              <a:t>Integrate PDEs over each control volume (cell)</a:t>
+            </a:r>
+          </a:p>
+          <a:p>
+            <a:r>
+              <a:rPr lang="en-US" dirty="0"/>
+              <a:t>Apply Gauss’ Divergence theorem to convert volume integral to surface integral</a:t>
+            </a:r>
+          </a:p>
+          <a:p>
+            <a:r>
+              <a:rPr lang="en-US" dirty="0"/>
+              <a:t>Momentum equation becomes a linear system per timestep</a:t>
+            </a:r>
+          </a:p>
+          <a:p>
+            <a:r>
+              <a:rPr lang="en-US" dirty="0"/>
+              <a:t>Pressure emerges from continuity.</a:t>
+            </a:r>
+          </a:p>
+        </p:txBody>
+      </p:sp>
+      <p:sp>
+        <p:nvSpPr>
+          <p:cNvPr id="4" name="Title 1">
+            <a:extLst>
+              <a:ext uri="{FF2B5EF4-FFF2-40B4-BE49-F238E27FC236}">
+                <a16:creationId xmlns:a16="http://schemas.microsoft.com/office/drawing/2014/main" id="{5AF153D4-2A99-BF13-549F-DC2FE4CEDD2C}"/>
+              </a:ext>
+            </a:extLst>
+          </p:cNvPr>
+          <p:cNvSpPr txBox="1">
+            <a:spLocks/>
+          </p:cNvSpPr>
+          <p:nvPr/>
+        </p:nvSpPr>
+        <p:spPr>
+          <a:xfrm>
+            <a:off x="1301071" y="3718229"/>
+            <a:ext cx="10890929" cy="1097280"/>
+          </a:xfrm>
+          <a:prstGeom prst="rect">
+            <a:avLst/>
+          </a:prstGeom>
+        </p:spPr>
+        <p:txBody>
+          <a:bodyPr vert="horz" lIns="91440" tIns="45720" rIns="91440" bIns="45720" rtlCol="0" anchor="t">
+            <a:normAutofit/>
+          </a:bodyPr>
+          <a:lstStyle>
+            <a:lvl1pPr algn="l" defTabSz="914400" rtl="0" eaLnBrk="1" latinLnBrk="0" hangingPunct="1">
+              <a:lnSpc>
+                <a:spcPct val="100000"/>
+              </a:lnSpc>
+              <a:spcBef>
+                <a:spcPct val="0"/>
+              </a:spcBef>
+              <a:buNone/>
+              <a:defRPr sz="4000" b="1" kern="1200">
+                <a:solidFill>
+                  <a:schemeClr val="tx1"/>
+                </a:solidFill>
+                <a:latin typeface="+mj-lt"/>
+                <a:ea typeface="+mj-ea"/>
+                <a:cs typeface="+mj-cs"/>
+              </a:defRPr>
+            </a:lvl1pPr>
+          </a:lstStyle>
+          <a:p>
+            <a:r>
+              <a:rPr lang="en-US" sz="3200" dirty="0"/>
+              <a:t>Finite Volume Discretization</a:t>
+            </a:r>
+          </a:p>
+        </p:txBody>
+      </p:sp>
+      <p:sp>
+        <p:nvSpPr>
+          <p:cNvPr id="8" name="Rectangle 7">
+            <a:extLst>
+              <a:ext uri="{FF2B5EF4-FFF2-40B4-BE49-F238E27FC236}">
+                <a16:creationId xmlns:a16="http://schemas.microsoft.com/office/drawing/2014/main" id="{6A49FFFD-19DC-3295-725C-A9ECD324C75C}"/>
+              </a:ext>
+            </a:extLst>
+          </p:cNvPr>
+          <p:cNvSpPr/>
+          <p:nvPr/>
+        </p:nvSpPr>
+        <p:spPr>
+          <a:xfrm>
+            <a:off x="1301069" y="2057400"/>
+            <a:ext cx="10890931" cy="1660829"/>
+          </a:xfrm>
+          <a:prstGeom prst="rect">
+            <a:avLst/>
+          </a:prstGeom>
+          <a:solidFill>
+            <a:schemeClr val="tx2">
+              <a:lumMod val="10000"/>
+              <a:lumOff val="90000"/>
+            </a:schemeClr>
+          </a:solidFill>
+        </p:spPr>
+        <p:style>
+          <a:lnRef idx="2">
+            <a:schemeClr val="accent1">
+              <a:shade val="15000"/>
+            </a:schemeClr>
+          </a:lnRef>
+          <a:fillRef idx="1">
+            <a:schemeClr val="accent1"/>
+          </a:fillRef>
+          <a:effectRef idx="0">
+            <a:schemeClr val="accent1"/>
+          </a:effectRef>
+          <a:fontRef idx="minor">
+            <a:schemeClr val="lt1"/>
+          </a:fontRef>
+        </p:style>
+        <p:txBody>
+          <a:bodyPr rtlCol="0" anchor="ctr"/>
+          <a:lstStyle/>
+          <a:p>
+            <a:pPr algn="ctr"/>
             <a:endParaRPr lang="en-US"/>
           </a:p>
         </p:txBody>
       </p:sp>
+      <p:sp>
+        <p:nvSpPr>
+          <p:cNvPr id="5" name="Title 1">
+            <a:extLst>
+              <a:ext uri="{FF2B5EF4-FFF2-40B4-BE49-F238E27FC236}">
+                <a16:creationId xmlns:a16="http://schemas.microsoft.com/office/drawing/2014/main" id="{3F8D099D-7725-12F5-4824-27782DD47C40}"/>
+              </a:ext>
+            </a:extLst>
+          </p:cNvPr>
+          <p:cNvSpPr txBox="1">
+            <a:spLocks/>
+          </p:cNvSpPr>
+          <p:nvPr/>
+        </p:nvSpPr>
+        <p:spPr>
+          <a:xfrm>
+            <a:off x="1301070" y="2057400"/>
+            <a:ext cx="10890929" cy="1097280"/>
+          </a:xfrm>
+          <a:prstGeom prst="rect">
+            <a:avLst/>
+          </a:prstGeom>
+        </p:spPr>
+        <p:txBody>
+          <a:bodyPr vert="horz" lIns="91440" tIns="45720" rIns="91440" bIns="45720" rtlCol="0" anchor="t">
+            <a:normAutofit/>
+          </a:bodyPr>
+          <a:lstStyle>
+            <a:lvl1pPr algn="l" defTabSz="914400" rtl="0" eaLnBrk="1" latinLnBrk="0" hangingPunct="1">
+              <a:lnSpc>
+                <a:spcPct val="100000"/>
+              </a:lnSpc>
+              <a:spcBef>
+                <a:spcPct val="0"/>
+              </a:spcBef>
+              <a:buNone/>
+              <a:defRPr sz="4000" b="1" kern="1200">
+                <a:solidFill>
+                  <a:schemeClr val="tx1"/>
+                </a:solidFill>
+                <a:latin typeface="+mj-lt"/>
+                <a:ea typeface="+mj-ea"/>
+                <a:cs typeface="+mj-cs"/>
+              </a:defRPr>
+            </a:lvl1pPr>
+          </a:lstStyle>
+          <a:p>
+            <a:r>
+              <a:rPr lang="en-US" sz="3200" dirty="0"/>
+              <a:t>What is </a:t>
+            </a:r>
+            <a:r>
+              <a:rPr lang="en-US" sz="3200" dirty="0" err="1"/>
+              <a:t>openFoam</a:t>
+            </a:r>
+            <a:r>
+              <a:rPr lang="en-US" sz="3200" dirty="0"/>
+              <a:t>?</a:t>
+            </a:r>
+          </a:p>
+        </p:txBody>
+      </p:sp>
+      <mc:AlternateContent xmlns:mc="http://schemas.openxmlformats.org/markup-compatibility/2006">
+        <mc:Choice xmlns:a14="http://schemas.microsoft.com/office/drawing/2010/main" Requires="a14">
+          <p:sp>
+            <p:nvSpPr>
+              <p:cNvPr id="7" name="TextBox 6">
+                <a:extLst>
+                  <a:ext uri="{FF2B5EF4-FFF2-40B4-BE49-F238E27FC236}">
+                    <a16:creationId xmlns:a16="http://schemas.microsoft.com/office/drawing/2014/main" id="{2A1EE006-DAB7-9708-4FC3-B2582E84AB3B}"/>
+                  </a:ext>
+                </a:extLst>
+              </p:cNvPr>
+              <p:cNvSpPr txBox="1"/>
+              <p:nvPr/>
+            </p:nvSpPr>
+            <p:spPr>
+              <a:xfrm>
+                <a:off x="1461052" y="2763078"/>
+                <a:ext cx="6167073" cy="923330"/>
+              </a:xfrm>
+              <a:prstGeom prst="rect">
+                <a:avLst/>
+              </a:prstGeom>
+              <a:noFill/>
+            </p:spPr>
+            <p:txBody>
+              <a:bodyPr wrap="none" rtlCol="0">
+                <a:spAutoFit/>
+              </a:bodyPr>
+              <a:lstStyle/>
+              <a:p>
+                <a:pPr marL="285750" indent="-285750">
+                  <a:buFont typeface="Arial" panose="020B0604020202020204" pitchFamily="34" charset="0"/>
+                  <a:buChar char="•"/>
+                </a:pPr>
+                <a:r>
+                  <a:rPr lang="en-US" dirty="0"/>
+                  <a:t>Transient, incompressible, laminar Navier-Stokes solver</a:t>
+                </a:r>
+              </a:p>
+              <a:p>
+                <a:pPr marL="285750" indent="-285750">
+                  <a:buFont typeface="Arial" panose="020B0604020202020204" pitchFamily="34" charset="0"/>
+                  <a:buChar char="•"/>
+                </a:pPr>
+                <a:r>
+                  <a:rPr lang="en-US" dirty="0"/>
+                  <a:t>Cell-centered u and p with fluxes defined at faces</a:t>
+                </a:r>
+              </a:p>
+              <a:p>
+                <a:pPr marL="285750" indent="-285750">
+                  <a:buFont typeface="Arial" panose="020B0604020202020204" pitchFamily="34" charset="0"/>
+                  <a:buChar char="•"/>
+                </a:pPr>
+                <a:r>
+                  <a:rPr lang="en-US" dirty="0"/>
+                  <a:t>Continuity </a:t>
+                </a:r>
+                <a14:m>
+                  <m:oMath xmlns:m="http://schemas.openxmlformats.org/officeDocument/2006/math">
+                    <m:r>
+                      <a:rPr lang="nb-NO" b="0" i="0" smtClean="0">
+                        <a:latin typeface="Cambria Math" panose="02040503050406030204" pitchFamily="18" charset="0"/>
+                      </a:rPr>
+                      <m:t>(</m:t>
+                    </m:r>
+                    <m:r>
+                      <m:rPr>
+                        <m:sty m:val="p"/>
+                      </m:rPr>
+                      <a:rPr lang="nb-NO" b="0" i="0" smtClean="0">
+                        <a:latin typeface="Cambria Math" panose="02040503050406030204" pitchFamily="18" charset="0"/>
+                      </a:rPr>
+                      <m:t>∇</m:t>
+                    </m:r>
+                    <m:r>
+                      <a:rPr lang="nb-NO" b="0" i="1" smtClean="0">
+                        <a:latin typeface="Cambria Math" panose="02040503050406030204" pitchFamily="18" charset="0"/>
+                      </a:rPr>
+                      <m:t> ⋅</m:t>
+                    </m:r>
+                    <m:r>
+                      <a:rPr lang="nb-NO" b="0" i="1" smtClean="0">
+                        <a:latin typeface="Cambria Math" panose="02040503050406030204" pitchFamily="18" charset="0"/>
+                      </a:rPr>
+                      <m:t>𝐮</m:t>
+                    </m:r>
+                    <m:r>
+                      <a:rPr lang="nb-NO" b="0" i="1" smtClean="0">
+                        <a:latin typeface="Cambria Math" panose="02040503050406030204" pitchFamily="18" charset="0"/>
+                      </a:rPr>
+                      <m:t>)=0</m:t>
+                    </m:r>
+                  </m:oMath>
+                </a14:m>
+                <a:r>
+                  <a:rPr lang="en-US" dirty="0"/>
+                  <a:t> introduces coupling challenge</a:t>
+                </a:r>
+              </a:p>
+            </p:txBody>
+          </p:sp>
+        </mc:Choice>
+        <mc:Fallback>
+          <p:sp>
+            <p:nvSpPr>
+              <p:cNvPr id="7" name="TextBox 6">
+                <a:extLst>
+                  <a:ext uri="{FF2B5EF4-FFF2-40B4-BE49-F238E27FC236}">
+                    <a16:creationId xmlns:a16="http://schemas.microsoft.com/office/drawing/2014/main" id="{2A1EE006-DAB7-9708-4FC3-B2582E84AB3B}"/>
+                  </a:ext>
+                </a:extLst>
+              </p:cNvPr>
+              <p:cNvSpPr txBox="1">
+                <a:spLocks noRot="1" noChangeAspect="1" noMove="1" noResize="1" noEditPoints="1" noAdjustHandles="1" noChangeArrowheads="1" noChangeShapeType="1" noTextEdit="1"/>
+              </p:cNvSpPr>
+              <p:nvPr/>
+            </p:nvSpPr>
+            <p:spPr>
+              <a:xfrm>
+                <a:off x="1461052" y="2763078"/>
+                <a:ext cx="6167073" cy="923330"/>
+              </a:xfrm>
+              <a:prstGeom prst="rect">
+                <a:avLst/>
+              </a:prstGeom>
+              <a:blipFill>
+                <a:blip r:embed="rId2"/>
+                <a:stretch>
+                  <a:fillRect l="-823" t="-2703" b="-8108"/>
+                </a:stretch>
+              </a:blipFill>
+            </p:spPr>
+            <p:txBody>
+              <a:bodyPr/>
+              <a:lstStyle/>
+              <a:p>
+                <a:r>
+                  <a:rPr lang="en-US">
+                    <a:noFill/>
+                  </a:rPr>
+                  <a:t> </a:t>
+                </a:r>
+              </a:p>
+            </p:txBody>
+          </p:sp>
+        </mc:Fallback>
+      </mc:AlternateContent>
     </p:spTree>
     <p:extLst>
       <p:ext uri="{BB962C8B-B14F-4D97-AF65-F5344CB8AC3E}">
-        <p14:creationId xmlns:p14="http://schemas.microsoft.com/office/powerpoint/2010/main" val="2598518009"/>
+        <p14:creationId xmlns:p14="http://schemas.microsoft.com/office/powerpoint/2010/main" val="1463697046"/>
       </p:ext>
     </p:extLst>
   </p:cSld>
@@ -5210,7 +5905,13 @@
   <p:cSld>
     <p:spTree>
       <p:nvGrpSpPr>
-        <p:cNvPr id="1" name=""/>
+        <p:cNvPr id="1" name="">
+          <a:extLst>
+            <a:ext uri="{FF2B5EF4-FFF2-40B4-BE49-F238E27FC236}">
+              <a16:creationId xmlns:a16="http://schemas.microsoft.com/office/drawing/2014/main" id="{A97B19B7-7DE3-B655-4D36-A9FBCDDC8E6E}"/>
+            </a:ext>
+          </a:extLst>
+        </p:cNvPr>
         <p:cNvGrpSpPr/>
         <p:nvPr/>
       </p:nvGrpSpPr>
@@ -5227,7 +5928,7 @@
           <p:cNvPr id="2" name="Title 1">
             <a:extLst>
               <a:ext uri="{FF2B5EF4-FFF2-40B4-BE49-F238E27FC236}">
-                <a16:creationId xmlns:a16="http://schemas.microsoft.com/office/drawing/2014/main" id="{0BEFB0F0-9D33-7833-091B-06BA37CB6A64}"/>
+                <a16:creationId xmlns:a16="http://schemas.microsoft.com/office/drawing/2014/main" id="{125108ED-23DF-3D9D-5F3A-DA6D469FA8A2}"/>
               </a:ext>
             </a:extLst>
           </p:cNvPr>
@@ -5245,40 +5946,405 @@
           <a:p>
             <a:r>
               <a:rPr lang="en-US" dirty="0"/>
-              <a:t>Results at Re=200</a:t>
-            </a:r>
-          </a:p>
-        </p:txBody>
-      </p:sp>
-      <p:sp>
-        <p:nvSpPr>
-          <p:cNvPr id="3" name="Content Placeholder 2">
-            <a:extLst>
-              <a:ext uri="{FF2B5EF4-FFF2-40B4-BE49-F238E27FC236}">
-                <a16:creationId xmlns:a16="http://schemas.microsoft.com/office/drawing/2014/main" id="{64009468-F970-CF2A-5411-CE3546C29415}"/>
-              </a:ext>
-            </a:extLst>
-          </p:cNvPr>
-          <p:cNvSpPr>
-            <a:spLocks noGrp="1"/>
-          </p:cNvSpPr>
-          <p:nvPr>
-            <p:ph idx="1"/>
-          </p:nvPr>
-        </p:nvSpPr>
-        <p:spPr/>
-        <p:txBody>
-          <a:bodyPr/>
-          <a:lstStyle/>
-          <a:p>
+              <a:t>Solver 1: </a:t>
+            </a:r>
+            <a:r>
+              <a:rPr lang="en-US" dirty="0" err="1"/>
+              <a:t>OpenFoam</a:t>
+            </a:r>
+            <a:endParaRPr lang="en-US" dirty="0"/>
+          </a:p>
+        </p:txBody>
+      </p:sp>
+      <p:sp>
+        <p:nvSpPr>
+          <p:cNvPr id="5" name="Rectangle 4">
+            <a:extLst>
+              <a:ext uri="{FF2B5EF4-FFF2-40B4-BE49-F238E27FC236}">
+                <a16:creationId xmlns:a16="http://schemas.microsoft.com/office/drawing/2014/main" id="{A9438689-6394-4F95-D9F4-3F2B28E36F7D}"/>
+              </a:ext>
+            </a:extLst>
+          </p:cNvPr>
+          <p:cNvSpPr/>
+          <p:nvPr/>
+        </p:nvSpPr>
+        <p:spPr>
+          <a:xfrm>
+            <a:off x="1301071" y="2034540"/>
+            <a:ext cx="10890929" cy="3556220"/>
+          </a:xfrm>
+          <a:prstGeom prst="rect">
+            <a:avLst/>
+          </a:prstGeom>
+          <a:solidFill>
+            <a:schemeClr val="tx2">
+              <a:lumMod val="25000"/>
+              <a:lumOff val="75000"/>
+            </a:schemeClr>
+          </a:solidFill>
+        </p:spPr>
+        <p:style>
+          <a:lnRef idx="2">
+            <a:schemeClr val="accent1">
+              <a:shade val="15000"/>
+            </a:schemeClr>
+          </a:lnRef>
+          <a:fillRef idx="1">
+            <a:schemeClr val="accent1"/>
+          </a:fillRef>
+          <a:effectRef idx="0">
+            <a:schemeClr val="accent1"/>
+          </a:effectRef>
+          <a:fontRef idx="minor">
+            <a:schemeClr val="lt1"/>
+          </a:fontRef>
+        </p:style>
+        <p:txBody>
+          <a:bodyPr rtlCol="0" anchor="ctr"/>
+          <a:lstStyle/>
+          <a:p>
+            <a:pPr algn="ctr"/>
             <a:endParaRPr lang="en-US"/>
+          </a:p>
+        </p:txBody>
+      </p:sp>
+      <mc:AlternateContent xmlns:mc="http://schemas.openxmlformats.org/markup-compatibility/2006">
+        <mc:Choice xmlns:a14="http://schemas.microsoft.com/office/drawing/2010/main" Requires="a14">
+          <p:sp>
+            <p:nvSpPr>
+              <p:cNvPr id="3" name="Content Placeholder 2">
+                <a:extLst>
+                  <a:ext uri="{FF2B5EF4-FFF2-40B4-BE49-F238E27FC236}">
+                    <a16:creationId xmlns:a16="http://schemas.microsoft.com/office/drawing/2014/main" id="{E87CEE18-CB53-4F89-4E5B-9A641D69B6EA}"/>
+                  </a:ext>
+                </a:extLst>
+              </p:cNvPr>
+              <p:cNvSpPr>
+                <a:spLocks noGrp="1"/>
+              </p:cNvSpPr>
+              <p:nvPr>
+                <p:ph idx="1"/>
+              </p:nvPr>
+            </p:nvSpPr>
+            <p:spPr>
+              <a:xfrm>
+                <a:off x="1301071" y="2715370"/>
+                <a:ext cx="10890928" cy="3566160"/>
+              </a:xfrm>
+            </p:spPr>
+            <p:txBody>
+              <a:bodyPr/>
+              <a:lstStyle/>
+              <a:p>
+                <a:r>
+                  <a:rPr lang="en-US" dirty="0"/>
+                  <a:t>Predictor: solve momentum equation with lagged pressure. </a:t>
+                </a:r>
+                <a14:m>
+                  <m:oMath xmlns:m="http://schemas.openxmlformats.org/officeDocument/2006/math">
+                    <m:sSup>
+                      <m:sSupPr>
+                        <m:ctrlPr>
+                          <a:rPr lang="nb-NO" b="0" i="1" smtClean="0">
+                            <a:latin typeface="Cambria Math" panose="02040503050406030204" pitchFamily="18" charset="0"/>
+                          </a:rPr>
+                        </m:ctrlPr>
+                      </m:sSupPr>
+                      <m:e>
+                        <m:r>
+                          <a:rPr lang="nb-NO" b="0" i="1" smtClean="0">
+                            <a:latin typeface="Cambria Math" panose="02040503050406030204" pitchFamily="18" charset="0"/>
+                          </a:rPr>
+                          <m:t>𝑢</m:t>
+                        </m:r>
+                      </m:e>
+                      <m:sup>
+                        <m:r>
+                          <a:rPr lang="nb-NO" b="0" i="1" smtClean="0">
+                            <a:latin typeface="Cambria Math" panose="02040503050406030204" pitchFamily="18" charset="0"/>
+                          </a:rPr>
+                          <m:t>∗</m:t>
+                        </m:r>
+                      </m:sup>
+                    </m:sSup>
+                  </m:oMath>
+                </a14:m>
+                <a:r>
+                  <a:rPr lang="en-US" dirty="0"/>
+                  <a:t> is not divergence free.</a:t>
+                </a:r>
+              </a:p>
+              <a:p>
+                <a:r>
+                  <a:rPr lang="en-US" dirty="0"/>
+                  <a:t>Pressure solve: Poisson equation </a:t>
+                </a:r>
+                <a14:m>
+                  <m:oMath xmlns:m="http://schemas.openxmlformats.org/officeDocument/2006/math">
+                    <m:r>
+                      <m:rPr>
+                        <m:sty m:val="p"/>
+                      </m:rPr>
+                      <a:rPr lang="nb-NO" b="0" i="0" smtClean="0">
+                        <a:latin typeface="Cambria Math" panose="02040503050406030204" pitchFamily="18" charset="0"/>
+                      </a:rPr>
+                      <m:t>∇</m:t>
+                    </m:r>
+                    <m:r>
+                      <a:rPr lang="nb-NO" b="0" i="1" smtClean="0">
+                        <a:latin typeface="Cambria Math" panose="02040503050406030204" pitchFamily="18" charset="0"/>
+                      </a:rPr>
+                      <m:t>⋅</m:t>
+                    </m:r>
+                    <m:d>
+                      <m:dPr>
+                        <m:ctrlPr>
+                          <a:rPr lang="nb-NO" b="0" i="1" smtClean="0">
+                            <a:latin typeface="Cambria Math" panose="02040503050406030204" pitchFamily="18" charset="0"/>
+                          </a:rPr>
+                        </m:ctrlPr>
+                      </m:dPr>
+                      <m:e>
+                        <m:d>
+                          <m:dPr>
+                            <m:ctrlPr>
+                              <a:rPr lang="nb-NO" b="0" i="1" smtClean="0">
+                                <a:latin typeface="Cambria Math" panose="02040503050406030204" pitchFamily="18" charset="0"/>
+                              </a:rPr>
+                            </m:ctrlPr>
+                          </m:dPr>
+                          <m:e>
+                            <m:f>
+                              <m:fPr>
+                                <m:ctrlPr>
+                                  <a:rPr lang="nb-NO" b="0" i="1" smtClean="0">
+                                    <a:latin typeface="Cambria Math" panose="02040503050406030204" pitchFamily="18" charset="0"/>
+                                  </a:rPr>
+                                </m:ctrlPr>
+                              </m:fPr>
+                              <m:num>
+                                <m:r>
+                                  <a:rPr lang="nb-NO" b="0" i="1" smtClean="0">
+                                    <a:latin typeface="Cambria Math" panose="02040503050406030204" pitchFamily="18" charset="0"/>
+                                  </a:rPr>
+                                  <m:t>1</m:t>
+                                </m:r>
+                              </m:num>
+                              <m:den>
+                                <m:r>
+                                  <a:rPr lang="nb-NO" b="0" i="1" smtClean="0">
+                                    <a:latin typeface="Cambria Math" panose="02040503050406030204" pitchFamily="18" charset="0"/>
+                                  </a:rPr>
+                                  <m:t>𝐴</m:t>
+                                </m:r>
+                              </m:den>
+                            </m:f>
+                          </m:e>
+                        </m:d>
+                        <m:r>
+                          <m:rPr>
+                            <m:sty m:val="p"/>
+                          </m:rPr>
+                          <a:rPr lang="nb-NO" b="0" i="0" smtClean="0">
+                            <a:latin typeface="Cambria Math" panose="02040503050406030204" pitchFamily="18" charset="0"/>
+                          </a:rPr>
+                          <m:t>∇</m:t>
+                        </m:r>
+                        <m:r>
+                          <a:rPr lang="nb-NO" b="0" i="1" smtClean="0">
+                            <a:latin typeface="Cambria Math" panose="02040503050406030204" pitchFamily="18" charset="0"/>
+                          </a:rPr>
+                          <m:t>𝑝</m:t>
+                        </m:r>
+                      </m:e>
+                    </m:d>
+                    <m:r>
+                      <a:rPr lang="nb-NO" b="0" i="1" smtClean="0">
+                        <a:latin typeface="Cambria Math" panose="02040503050406030204" pitchFamily="18" charset="0"/>
+                      </a:rPr>
+                      <m:t>=</m:t>
+                    </m:r>
+                    <m:r>
+                      <m:rPr>
+                        <m:sty m:val="p"/>
+                      </m:rPr>
+                      <a:rPr lang="nb-NO" b="0" i="0" smtClean="0">
+                        <a:latin typeface="Cambria Math" panose="02040503050406030204" pitchFamily="18" charset="0"/>
+                      </a:rPr>
+                      <m:t>∇</m:t>
+                    </m:r>
+                    <m:r>
+                      <a:rPr lang="nb-NO" b="0" i="1" smtClean="0">
+                        <a:latin typeface="Cambria Math" panose="02040503050406030204" pitchFamily="18" charset="0"/>
+                      </a:rPr>
+                      <m:t>⋅</m:t>
+                    </m:r>
+                    <m:d>
+                      <m:dPr>
+                        <m:ctrlPr>
+                          <a:rPr lang="nb-NO" b="0" i="1" smtClean="0">
+                            <a:latin typeface="Cambria Math" panose="02040503050406030204" pitchFamily="18" charset="0"/>
+                          </a:rPr>
+                        </m:ctrlPr>
+                      </m:dPr>
+                      <m:e>
+                        <m:f>
+                          <m:fPr>
+                            <m:ctrlPr>
+                              <a:rPr lang="nb-NO" b="0" i="1" smtClean="0">
+                                <a:latin typeface="Cambria Math" panose="02040503050406030204" pitchFamily="18" charset="0"/>
+                              </a:rPr>
+                            </m:ctrlPr>
+                          </m:fPr>
+                          <m:num>
+                            <m:r>
+                              <a:rPr lang="nb-NO" b="0" i="1" smtClean="0">
+                                <a:latin typeface="Cambria Math" panose="02040503050406030204" pitchFamily="18" charset="0"/>
+                              </a:rPr>
+                              <m:t>𝐻</m:t>
+                            </m:r>
+                          </m:num>
+                          <m:den>
+                            <m:r>
+                              <a:rPr lang="nb-NO" b="0" i="1" smtClean="0">
+                                <a:latin typeface="Cambria Math" panose="02040503050406030204" pitchFamily="18" charset="0"/>
+                              </a:rPr>
+                              <m:t>𝐴</m:t>
+                            </m:r>
+                          </m:den>
+                        </m:f>
+                      </m:e>
+                    </m:d>
+                  </m:oMath>
+                </a14:m>
+                <a:r>
+                  <a:rPr lang="en-US" dirty="0"/>
+                  <a:t> enforces continuity</a:t>
+                </a:r>
+              </a:p>
+              <a:p>
+                <a:r>
+                  <a:rPr lang="en-US" dirty="0"/>
+                  <a:t>Corrector: update u and face fluxes with new pressure</a:t>
+                </a:r>
+              </a:p>
+              <a:p>
+                <a:r>
+                  <a:rPr lang="en-US" dirty="0"/>
+                  <a:t>Repeat 2-3 times per timestep to reduce splitting error</a:t>
+                </a:r>
+              </a:p>
+              <a:p>
+                <a:r>
+                  <a:rPr lang="en-US" dirty="0"/>
+                  <a:t>Requires CFL &lt; 1 (Explicit convection)</a:t>
+                </a:r>
+              </a:p>
+            </p:txBody>
+          </p:sp>
+        </mc:Choice>
+        <mc:Fallback>
+          <p:sp>
+            <p:nvSpPr>
+              <p:cNvPr id="3" name="Content Placeholder 2">
+                <a:extLst>
+                  <a:ext uri="{FF2B5EF4-FFF2-40B4-BE49-F238E27FC236}">
+                    <a16:creationId xmlns:a16="http://schemas.microsoft.com/office/drawing/2014/main" id="{E87CEE18-CB53-4F89-4E5B-9A641D69B6EA}"/>
+                  </a:ext>
+                </a:extLst>
+              </p:cNvPr>
+              <p:cNvSpPr>
+                <a:spLocks noGrp="1" noRot="1" noChangeAspect="1" noMove="1" noResize="1" noEditPoints="1" noAdjustHandles="1" noChangeArrowheads="1" noChangeShapeType="1" noTextEdit="1"/>
+              </p:cNvSpPr>
+              <p:nvPr>
+                <p:ph idx="1"/>
+              </p:nvPr>
+            </p:nvSpPr>
+            <p:spPr>
+              <a:xfrm>
+                <a:off x="1301071" y="2715370"/>
+                <a:ext cx="10890928" cy="3566160"/>
+              </a:xfrm>
+              <a:blipFill>
+                <a:blip r:embed="rId2"/>
+                <a:stretch>
+                  <a:fillRect l="-349"/>
+                </a:stretch>
+              </a:blipFill>
+            </p:spPr>
+            <p:txBody>
+              <a:bodyPr/>
+              <a:lstStyle/>
+              <a:p>
+                <a:r>
+                  <a:rPr lang="en-US">
+                    <a:noFill/>
+                  </a:rPr>
+                  <a:t> </a:t>
+                </a:r>
+              </a:p>
+            </p:txBody>
+          </p:sp>
+        </mc:Fallback>
+      </mc:AlternateContent>
+      <p:sp>
+        <p:nvSpPr>
+          <p:cNvPr id="4" name="Title 1">
+            <a:extLst>
+              <a:ext uri="{FF2B5EF4-FFF2-40B4-BE49-F238E27FC236}">
+                <a16:creationId xmlns:a16="http://schemas.microsoft.com/office/drawing/2014/main" id="{6499EF5D-2E0E-041B-3F56-3021B7467160}"/>
+              </a:ext>
+            </a:extLst>
+          </p:cNvPr>
+          <p:cNvSpPr txBox="1">
+            <a:spLocks/>
+          </p:cNvSpPr>
+          <p:nvPr/>
+        </p:nvSpPr>
+        <p:spPr>
+          <a:xfrm>
+            <a:off x="1301071" y="1920241"/>
+            <a:ext cx="10890929" cy="1097280"/>
+          </a:xfrm>
+          <a:prstGeom prst="rect">
+            <a:avLst/>
+          </a:prstGeom>
+        </p:spPr>
+        <p:txBody>
+          <a:bodyPr vert="horz" lIns="91440" tIns="45720" rIns="91440" bIns="45720" rtlCol="0" anchor="t">
+            <a:normAutofit/>
+          </a:bodyPr>
+          <a:lstStyle>
+            <a:lvl1pPr algn="l" defTabSz="914400" rtl="0" eaLnBrk="1" latinLnBrk="0" hangingPunct="1">
+              <a:lnSpc>
+                <a:spcPct val="100000"/>
+              </a:lnSpc>
+              <a:spcBef>
+                <a:spcPct val="0"/>
+              </a:spcBef>
+              <a:buNone/>
+              <a:defRPr sz="4000" b="1" kern="1200">
+                <a:solidFill>
+                  <a:schemeClr val="tx1"/>
+                </a:solidFill>
+                <a:latin typeface="+mj-lt"/>
+                <a:ea typeface="+mj-ea"/>
+                <a:cs typeface="+mj-cs"/>
+              </a:defRPr>
+            </a:lvl1pPr>
+          </a:lstStyle>
+          <a:p>
+            <a:r>
+              <a:rPr lang="en-US" sz="3200" dirty="0"/>
+              <a:t>Piso Algorithm</a:t>
+            </a:r>
           </a:p>
         </p:txBody>
       </p:sp>
     </p:spTree>
     <p:extLst>
       <p:ext uri="{BB962C8B-B14F-4D97-AF65-F5344CB8AC3E}">
-        <p14:creationId xmlns:p14="http://schemas.microsoft.com/office/powerpoint/2010/main" val="1841831974"/>
+        <p14:creationId xmlns:p14="http://schemas.microsoft.com/office/powerpoint/2010/main" val="689377269"/>
       </p:ext>
     </p:extLst>
   </p:cSld>
@@ -5310,7 +6376,7 @@
           <p:cNvPr id="2" name="Title 1">
             <a:extLst>
               <a:ext uri="{FF2B5EF4-FFF2-40B4-BE49-F238E27FC236}">
-                <a16:creationId xmlns:a16="http://schemas.microsoft.com/office/drawing/2014/main" id="{515984D7-D2CE-D5F3-4D33-71550CF3C5CB}"/>
+                <a16:creationId xmlns:a16="http://schemas.microsoft.com/office/drawing/2014/main" id="{93D60F15-EB9B-302A-A859-87B8B6C516A4}"/>
               </a:ext>
             </a:extLst>
           </p:cNvPr>
@@ -5328,40 +6394,347 @@
           <a:p>
             <a:r>
               <a:rPr lang="en-US" dirty="0"/>
-              <a:t>Results at Re=1000</a:t>
-            </a:r>
-          </a:p>
-        </p:txBody>
-      </p:sp>
-      <p:sp>
-        <p:nvSpPr>
-          <p:cNvPr id="3" name="Content Placeholder 2">
-            <a:extLst>
-              <a:ext uri="{FF2B5EF4-FFF2-40B4-BE49-F238E27FC236}">
-                <a16:creationId xmlns:a16="http://schemas.microsoft.com/office/drawing/2014/main" id="{885C0D54-99DD-E31E-26DB-A88D993E79D8}"/>
-              </a:ext>
-            </a:extLst>
-          </p:cNvPr>
-          <p:cNvSpPr>
-            <a:spLocks noGrp="1"/>
-          </p:cNvSpPr>
+              <a:t>Solver 2: Physics-Informed Neural Networks</a:t>
+            </a:r>
+          </a:p>
+        </p:txBody>
+      </p:sp>
+      <p:graphicFrame>
+        <p:nvGraphicFramePr>
+          <p:cNvPr id="5" name="Content Placeholder 4">
+            <a:extLst>
+              <a:ext uri="{FF2B5EF4-FFF2-40B4-BE49-F238E27FC236}">
+                <a16:creationId xmlns:a16="http://schemas.microsoft.com/office/drawing/2014/main" id="{82477CFF-7FF1-01C9-5FC1-46938B5B843F}"/>
+              </a:ext>
+            </a:extLst>
+          </p:cNvPr>
+          <p:cNvGraphicFramePr>
+            <a:graphicFrameLocks noGrp="1"/>
+          </p:cNvGraphicFramePr>
           <p:nvPr>
             <p:ph idx="1"/>
-          </p:nvPr>
-        </p:nvSpPr>
-        <p:spPr/>
-        <p:txBody>
-          <a:bodyPr/>
-          <a:lstStyle/>
-          <a:p>
-            <a:endParaRPr lang="en-US"/>
+            <p:extLst>
+              <p:ext uri="{D42A27DB-BD31-4B8C-83A1-F6EECF244321}">
+                <p14:modId xmlns:p14="http://schemas.microsoft.com/office/powerpoint/2010/main" val="598151417"/>
+              </p:ext>
+            </p:extLst>
+          </p:nvPr>
+        </p:nvGraphicFramePr>
+        <p:xfrm>
+          <a:off x="639172" y="4671185"/>
+          <a:ext cx="10891836" cy="1854200"/>
+        </p:xfrm>
+        <a:graphic>
+          <a:graphicData uri="http://schemas.openxmlformats.org/drawingml/2006/table">
+            <a:tbl>
+              <a:tblPr firstRow="1" bandRow="1">
+                <a:tableStyleId>{5C22544A-7EE6-4342-B048-85BDC9FD1C3A}</a:tableStyleId>
+              </a:tblPr>
+              <a:tblGrid>
+                <a:gridCol w="5445918">
+                  <a:extLst>
+                    <a:ext uri="{9D8B030D-6E8A-4147-A177-3AD203B41FA5}">
+                      <a16:colId xmlns:a16="http://schemas.microsoft.com/office/drawing/2014/main" val="1905779268"/>
+                    </a:ext>
+                  </a:extLst>
+                </a:gridCol>
+                <a:gridCol w="5445918">
+                  <a:extLst>
+                    <a:ext uri="{9D8B030D-6E8A-4147-A177-3AD203B41FA5}">
+                      <a16:colId xmlns:a16="http://schemas.microsoft.com/office/drawing/2014/main" val="3756693606"/>
+                    </a:ext>
+                  </a:extLst>
+                </a:gridCol>
+              </a:tblGrid>
+              <a:tr h="370840">
+                <a:tc>
+                  <a:txBody>
+                    <a:bodyPr/>
+                    <a:lstStyle/>
+                    <a:p>
+                      <a:r>
+                        <a:rPr lang="en-US" dirty="0" err="1"/>
+                        <a:t>openFoam</a:t>
+                      </a:r>
+                      <a:endParaRPr lang="en-US" dirty="0"/>
+                    </a:p>
+                  </a:txBody>
+                  <a:tcPr/>
+                </a:tc>
+                <a:tc>
+                  <a:txBody>
+                    <a:bodyPr/>
+                    <a:lstStyle/>
+                    <a:p>
+                      <a:r>
+                        <a:rPr lang="en-US" dirty="0"/>
+                        <a:t>Pinn</a:t>
+                      </a:r>
+                    </a:p>
+                  </a:txBody>
+                  <a:tcPr/>
+                </a:tc>
+                <a:extLst>
+                  <a:ext uri="{0D108BD9-81ED-4DB2-BD59-A6C34878D82A}">
+                    <a16:rowId xmlns:a16="http://schemas.microsoft.com/office/drawing/2014/main" val="3005336221"/>
+                  </a:ext>
+                </a:extLst>
+              </a:tr>
+              <a:tr h="370840">
+                <a:tc>
+                  <a:txBody>
+                    <a:bodyPr/>
+                    <a:lstStyle/>
+                    <a:p>
+                      <a:r>
+                        <a:rPr lang="en-US" dirty="0"/>
+                        <a:t>Mesh</a:t>
+                      </a:r>
+                    </a:p>
+                  </a:txBody>
+                  <a:tcPr/>
+                </a:tc>
+                <a:tc>
+                  <a:txBody>
+                    <a:bodyPr/>
+                    <a:lstStyle/>
+                    <a:p>
+                      <a:r>
+                        <a:rPr lang="en-US" dirty="0"/>
+                        <a:t>Collocation points</a:t>
+                      </a:r>
+                    </a:p>
+                  </a:txBody>
+                  <a:tcPr/>
+                </a:tc>
+                <a:extLst>
+                  <a:ext uri="{0D108BD9-81ED-4DB2-BD59-A6C34878D82A}">
+                    <a16:rowId xmlns:a16="http://schemas.microsoft.com/office/drawing/2014/main" val="152984949"/>
+                  </a:ext>
+                </a:extLst>
+              </a:tr>
+              <a:tr h="370840">
+                <a:tc>
+                  <a:txBody>
+                    <a:bodyPr/>
+                    <a:lstStyle/>
+                    <a:p>
+                      <a:r>
+                        <a:rPr lang="en-US" dirty="0"/>
+                        <a:t>FVM </a:t>
+                      </a:r>
+                      <a:r>
+                        <a:rPr lang="en-US" dirty="0" err="1"/>
+                        <a:t>discretizatrion</a:t>
+                      </a:r>
+                      <a:endParaRPr lang="en-US" dirty="0"/>
+                    </a:p>
+                  </a:txBody>
+                  <a:tcPr/>
+                </a:tc>
+                <a:tc>
+                  <a:txBody>
+                    <a:bodyPr/>
+                    <a:lstStyle/>
+                    <a:p>
+                      <a:r>
+                        <a:rPr lang="en-US" dirty="0"/>
+                        <a:t>Automatic differentiation via JAX</a:t>
+                      </a:r>
+                    </a:p>
+                  </a:txBody>
+                  <a:tcPr/>
+                </a:tc>
+                <a:extLst>
+                  <a:ext uri="{0D108BD9-81ED-4DB2-BD59-A6C34878D82A}">
+                    <a16:rowId xmlns:a16="http://schemas.microsoft.com/office/drawing/2014/main" val="86595439"/>
+                  </a:ext>
+                </a:extLst>
+              </a:tr>
+              <a:tr h="370840">
+                <a:tc>
+                  <a:txBody>
+                    <a:bodyPr/>
+                    <a:lstStyle/>
+                    <a:p>
+                      <a:r>
+                        <a:rPr lang="en-US" dirty="0"/>
+                        <a:t>PISO pressure-velocity coupling</a:t>
+                      </a:r>
+                    </a:p>
+                  </a:txBody>
+                  <a:tcPr/>
+                </a:tc>
+                <a:tc>
+                  <a:txBody>
+                    <a:bodyPr/>
+                    <a:lstStyle/>
+                    <a:p>
+                      <a:r>
+                        <a:rPr lang="en-US" dirty="0"/>
+                        <a:t>continuity is enforced through loss function</a:t>
+                      </a:r>
+                    </a:p>
+                  </a:txBody>
+                  <a:tcPr/>
+                </a:tc>
+                <a:extLst>
+                  <a:ext uri="{0D108BD9-81ED-4DB2-BD59-A6C34878D82A}">
+                    <a16:rowId xmlns:a16="http://schemas.microsoft.com/office/drawing/2014/main" val="1554622976"/>
+                  </a:ext>
+                </a:extLst>
+              </a:tr>
+              <a:tr h="370840">
+                <a:tc>
+                  <a:txBody>
+                    <a:bodyPr/>
+                    <a:lstStyle/>
+                    <a:p>
+                      <a:r>
+                        <a:rPr lang="en-US" dirty="0"/>
+                        <a:t>Linear solver per timestep</a:t>
+                      </a:r>
+                    </a:p>
+                  </a:txBody>
+                  <a:tcPr/>
+                </a:tc>
+                <a:tc>
+                  <a:txBody>
+                    <a:bodyPr/>
+                    <a:lstStyle/>
+                    <a:p>
+                      <a:r>
+                        <a:rPr lang="en-US" dirty="0"/>
+                        <a:t>Gradient descent over all time  </a:t>
+                      </a:r>
+                    </a:p>
+                  </a:txBody>
+                  <a:tcPr/>
+                </a:tc>
+                <a:extLst>
+                  <a:ext uri="{0D108BD9-81ED-4DB2-BD59-A6C34878D82A}">
+                    <a16:rowId xmlns:a16="http://schemas.microsoft.com/office/drawing/2014/main" val="478575766"/>
+                  </a:ext>
+                </a:extLst>
+              </a:tr>
+            </a:tbl>
+          </a:graphicData>
+        </a:graphic>
+      </p:graphicFrame>
+      <p:sp>
+        <p:nvSpPr>
+          <p:cNvPr id="4" name="Title 1">
+            <a:extLst>
+              <a:ext uri="{FF2B5EF4-FFF2-40B4-BE49-F238E27FC236}">
+                <a16:creationId xmlns:a16="http://schemas.microsoft.com/office/drawing/2014/main" id="{6B55262A-29F4-2812-2596-FC2B5833BA7F}"/>
+              </a:ext>
+            </a:extLst>
+          </p:cNvPr>
+          <p:cNvSpPr txBox="1">
+            <a:spLocks/>
+          </p:cNvSpPr>
+          <p:nvPr/>
+        </p:nvSpPr>
+        <p:spPr>
+          <a:xfrm>
+            <a:off x="1430280" y="2049450"/>
+            <a:ext cx="10890929" cy="548640"/>
+          </a:xfrm>
+          <a:prstGeom prst="rect">
+            <a:avLst/>
+          </a:prstGeom>
+        </p:spPr>
+        <p:txBody>
+          <a:bodyPr vert="horz" lIns="91440" tIns="45720" rIns="91440" bIns="45720" rtlCol="0" anchor="t">
+            <a:normAutofit lnSpcReduction="10000"/>
+          </a:bodyPr>
+          <a:lstStyle>
+            <a:lvl1pPr algn="l" defTabSz="914400" rtl="0" eaLnBrk="1" latinLnBrk="0" hangingPunct="1">
+              <a:lnSpc>
+                <a:spcPct val="100000"/>
+              </a:lnSpc>
+              <a:spcBef>
+                <a:spcPct val="0"/>
+              </a:spcBef>
+              <a:buNone/>
+              <a:defRPr sz="4000" b="1" kern="1200">
+                <a:solidFill>
+                  <a:schemeClr val="tx1"/>
+                </a:solidFill>
+                <a:latin typeface="+mj-lt"/>
+                <a:ea typeface="+mj-ea"/>
+                <a:cs typeface="+mj-cs"/>
+              </a:defRPr>
+            </a:lvl1pPr>
+          </a:lstStyle>
+          <a:p>
+            <a:r>
+              <a:rPr lang="en-US" sz="3200" dirty="0"/>
+              <a:t>What are PINNs?</a:t>
+            </a:r>
+          </a:p>
+        </p:txBody>
+      </p:sp>
+      <p:sp>
+        <p:nvSpPr>
+          <p:cNvPr id="6" name="TextBox 5">
+            <a:extLst>
+              <a:ext uri="{FF2B5EF4-FFF2-40B4-BE49-F238E27FC236}">
+                <a16:creationId xmlns:a16="http://schemas.microsoft.com/office/drawing/2014/main" id="{4CA5F18F-0867-C81C-0E48-71F66583E933}"/>
+              </a:ext>
+            </a:extLst>
+          </p:cNvPr>
+          <p:cNvSpPr txBox="1"/>
+          <p:nvPr/>
+        </p:nvSpPr>
+        <p:spPr>
+          <a:xfrm>
+            <a:off x="1103243" y="2812774"/>
+            <a:ext cx="6091732" cy="923330"/>
+          </a:xfrm>
+          <a:prstGeom prst="rect">
+            <a:avLst/>
+          </a:prstGeom>
+          <a:noFill/>
+        </p:spPr>
+        <p:txBody>
+          <a:bodyPr wrap="none" rtlCol="0">
+            <a:spAutoFit/>
+          </a:bodyPr>
+          <a:lstStyle/>
+          <a:p>
+            <a:pPr marL="285750" indent="-285750">
+              <a:buFont typeface="Arial" panose="020B0604020202020204" pitchFamily="34" charset="0"/>
+              <a:buChar char="•"/>
+            </a:pPr>
+            <a:r>
+              <a:rPr lang="en-US" dirty="0"/>
+              <a:t>Replaces mesh with a neural network (MLP)</a:t>
+            </a:r>
+          </a:p>
+          <a:p>
+            <a:pPr marL="285750" indent="-285750">
+              <a:buFont typeface="Arial" panose="020B0604020202020204" pitchFamily="34" charset="0"/>
+              <a:buChar char="•"/>
+            </a:pPr>
+            <a:r>
+              <a:rPr lang="en-US" dirty="0"/>
+              <a:t>PDE residual is embedded directly into the loss function</a:t>
+            </a:r>
+          </a:p>
+          <a:p>
+            <a:pPr marL="285750" indent="-285750">
+              <a:buFont typeface="Arial" panose="020B0604020202020204" pitchFamily="34" charset="0"/>
+              <a:buChar char="•"/>
+            </a:pPr>
+            <a:endParaRPr lang="en-US" dirty="0"/>
           </a:p>
         </p:txBody>
       </p:sp>
     </p:spTree>
     <p:extLst>
       <p:ext uri="{BB962C8B-B14F-4D97-AF65-F5344CB8AC3E}">
-        <p14:creationId xmlns:p14="http://schemas.microsoft.com/office/powerpoint/2010/main" val="1095544334"/>
+        <p14:creationId xmlns:p14="http://schemas.microsoft.com/office/powerpoint/2010/main" val="2598518009"/>
       </p:ext>
     </p:extLst>
   </p:cSld>
@@ -5390,10 +6763,45 @@
       </p:grpSpPr>
       <p:sp>
         <p:nvSpPr>
-          <p:cNvPr id="2" name="Title 1">
-            <a:extLst>
-              <a:ext uri="{FF2B5EF4-FFF2-40B4-BE49-F238E27FC236}">
-                <a16:creationId xmlns:a16="http://schemas.microsoft.com/office/drawing/2014/main" id="{FB2E32BB-25E9-27ED-B610-6A5E47A250EA}"/>
+          <p:cNvPr id="3" name="Content Placeholder 2">
+            <a:extLst>
+              <a:ext uri="{FF2B5EF4-FFF2-40B4-BE49-F238E27FC236}">
+                <a16:creationId xmlns:a16="http://schemas.microsoft.com/office/drawing/2014/main" id="{ADA918DA-17C1-9258-D11D-A16A9A6E9DB4}"/>
+              </a:ext>
+            </a:extLst>
+          </p:cNvPr>
+          <p:cNvSpPr>
+            <a:spLocks noGrp="1"/>
+          </p:cNvSpPr>
+          <p:nvPr>
+            <p:ph idx="1"/>
+          </p:nvPr>
+        </p:nvSpPr>
+        <p:spPr/>
+        <p:txBody>
+          <a:bodyPr/>
+          <a:lstStyle/>
+          <a:p>
+            <a:r>
+              <a:rPr lang="en-US" dirty="0"/>
+              <a:t>Network Architecture (MLP):</a:t>
+            </a:r>
+          </a:p>
+          <a:p>
+            <a:pPr lvl="1"/>
+            <a:r>
+              <a:rPr lang="en-US" dirty="0"/>
+              <a:t>4 hidden layers with 128 neurons each using tanh activation ()</a:t>
+            </a:r>
+          </a:p>
+        </p:txBody>
+      </p:sp>
+      <p:sp>
+        <p:nvSpPr>
+          <p:cNvPr id="4" name="Title 1">
+            <a:extLst>
+              <a:ext uri="{FF2B5EF4-FFF2-40B4-BE49-F238E27FC236}">
+                <a16:creationId xmlns:a16="http://schemas.microsoft.com/office/drawing/2014/main" id="{DAC03048-E37F-AD7E-802E-7E3FBF85BA4E}"/>
               </a:ext>
             </a:extLst>
           </p:cNvPr>
@@ -5411,40 +6819,69 @@
           <a:p>
             <a:r>
               <a:rPr lang="en-US" dirty="0"/>
-              <a:t>Strengths and Limitations</a:t>
-            </a:r>
-          </a:p>
-        </p:txBody>
-      </p:sp>
-      <p:sp>
-        <p:nvSpPr>
-          <p:cNvPr id="3" name="Content Placeholder 2">
-            <a:extLst>
-              <a:ext uri="{FF2B5EF4-FFF2-40B4-BE49-F238E27FC236}">
-                <a16:creationId xmlns:a16="http://schemas.microsoft.com/office/drawing/2014/main" id="{17574145-5798-88A0-0DA9-018F8901AD84}"/>
-              </a:ext>
-            </a:extLst>
-          </p:cNvPr>
-          <p:cNvSpPr>
-            <a:spLocks noGrp="1"/>
-          </p:cNvSpPr>
-          <p:nvPr>
-            <p:ph idx="1"/>
-          </p:nvPr>
-        </p:nvSpPr>
-        <p:spPr/>
-        <p:txBody>
-          <a:bodyPr/>
-          <a:lstStyle/>
-          <a:p>
-            <a:endParaRPr lang="en-US"/>
+              <a:t>Solver 2: Physics-Informed Neural Networks</a:t>
+            </a:r>
+          </a:p>
+        </p:txBody>
+      </p:sp>
+      <p:sp>
+        <p:nvSpPr>
+          <p:cNvPr id="5" name="Title 1">
+            <a:extLst>
+              <a:ext uri="{FF2B5EF4-FFF2-40B4-BE49-F238E27FC236}">
+                <a16:creationId xmlns:a16="http://schemas.microsoft.com/office/drawing/2014/main" id="{0533923A-E516-1ED4-235C-868AF0BFC5A5}"/>
+              </a:ext>
+            </a:extLst>
+          </p:cNvPr>
+          <p:cNvSpPr txBox="1">
+            <a:spLocks/>
+          </p:cNvSpPr>
+          <p:nvPr/>
+        </p:nvSpPr>
+        <p:spPr>
+          <a:xfrm>
+            <a:off x="1430280" y="2049450"/>
+            <a:ext cx="10890929" cy="548640"/>
+          </a:xfrm>
+          <a:prstGeom prst="rect">
+            <a:avLst/>
+          </a:prstGeom>
+        </p:spPr>
+        <p:txBody>
+          <a:bodyPr vert="horz" lIns="91440" tIns="45720" rIns="91440" bIns="45720" rtlCol="0" anchor="t">
+            <a:normAutofit lnSpcReduction="10000"/>
+          </a:bodyPr>
+          <a:lstStyle>
+            <a:lvl1pPr algn="l" defTabSz="914400" rtl="0" eaLnBrk="1" latinLnBrk="0" hangingPunct="1">
+              <a:lnSpc>
+                <a:spcPct val="100000"/>
+              </a:lnSpc>
+              <a:spcBef>
+                <a:spcPct val="0"/>
+              </a:spcBef>
+              <a:buNone/>
+              <a:defRPr sz="4000" b="1" kern="1200">
+                <a:solidFill>
+                  <a:schemeClr val="tx1"/>
+                </a:solidFill>
+                <a:latin typeface="+mj-lt"/>
+                <a:ea typeface="+mj-ea"/>
+                <a:cs typeface="+mj-cs"/>
+              </a:defRPr>
+            </a:lvl1pPr>
+          </a:lstStyle>
+          <a:p>
+            <a:r>
+              <a:rPr lang="en-US" sz="3200" dirty="0"/>
+              <a:t>PINN setup</a:t>
+            </a:r>
           </a:p>
         </p:txBody>
       </p:sp>
     </p:spTree>
     <p:extLst>
       <p:ext uri="{BB962C8B-B14F-4D97-AF65-F5344CB8AC3E}">
-        <p14:creationId xmlns:p14="http://schemas.microsoft.com/office/powerpoint/2010/main" val="505740524"/>
+        <p14:creationId xmlns:p14="http://schemas.microsoft.com/office/powerpoint/2010/main" val="1436160802"/>
       </p:ext>
     </p:extLst>
   </p:cSld>
@@ -5457,6 +6894,14 @@
 <file path=ppt/slides/slide8.xml><?xml version="1.0" encoding="utf-8"?>
 <p:sld xmlns:a="http://schemas.openxmlformats.org/drawingml/2006/main" xmlns:r="http://schemas.openxmlformats.org/officeDocument/2006/relationships" xmlns:p="http://schemas.openxmlformats.org/presentationml/2006/main">
   <p:cSld>
+    <p:bg>
+      <p:bgPr>
+        <a:solidFill>
+          <a:schemeClr val="bg1"/>
+        </a:solidFill>
+        <a:effectLst/>
+      </p:bgPr>
+    </p:bg>
     <p:spTree>
       <p:nvGrpSpPr>
         <p:cNvPr id="1" name=""/>
@@ -5471,12 +6916,136 @@
           <a:chExt cx="0" cy="0"/>
         </a:xfrm>
       </p:grpSpPr>
+      <p:cxnSp>
+        <p:nvCxnSpPr>
+          <p:cNvPr id="16" name="Straight Connector 15">
+            <a:extLst>
+              <a:ext uri="{FF2B5EF4-FFF2-40B4-BE49-F238E27FC236}">
+                <a16:creationId xmlns:a16="http://schemas.microsoft.com/office/drawing/2014/main" id="{118E06E4-607B-144B-382B-AD3D06B1EE8C}"/>
+              </a:ext>
+              <a:ext uri="{C183D7F6-B498-43B3-948B-1728B52AA6E4}">
+                <adec:decorative xmlns:adec="http://schemas.microsoft.com/office/drawing/2017/decorative" val="1"/>
+              </a:ext>
+            </a:extLst>
+          </p:cNvPr>
+          <p:cNvCxnSpPr>
+            <a:cxnSpLocks noGrp="1" noRot="1" noChangeAspect="1" noMove="1" noResize="1" noEditPoints="1" noAdjustHandles="1" noChangeArrowheads="1" noChangeShapeType="1"/>
+          </p:cNvCxnSpPr>
+          <p:nvPr>
+            <p:extLst>
+              <p:ext uri="{386F3935-93C4-4BCD-93E2-E3B085C9AB24}">
+                <p16:designElem xmlns:p16="http://schemas.microsoft.com/office/powerpoint/2015/main" val="1"/>
+              </p:ext>
+            </p:extLst>
+          </p:nvPr>
+        </p:nvCxnSpPr>
+        <p:spPr>
+          <a:xfrm>
+            <a:off x="713232" y="1031001"/>
+            <a:ext cx="978862" cy="0"/>
+          </a:xfrm>
+          <a:prstGeom prst="line">
+            <a:avLst/>
+          </a:prstGeom>
+          <a:ln w="76200"/>
+        </p:spPr>
+        <p:style>
+          <a:lnRef idx="1">
+            <a:schemeClr val="accent1"/>
+          </a:lnRef>
+          <a:fillRef idx="0">
+            <a:schemeClr val="accent1"/>
+          </a:fillRef>
+          <a:effectRef idx="0">
+            <a:schemeClr val="accent1"/>
+          </a:effectRef>
+          <a:fontRef idx="minor">
+            <a:schemeClr val="tx1"/>
+          </a:fontRef>
+        </p:style>
+      </p:cxnSp>
+      <p:sp useBgFill="1">
+        <p:nvSpPr>
+          <p:cNvPr id="18" name="Rectangle 17">
+            <a:extLst>
+              <a:ext uri="{FF2B5EF4-FFF2-40B4-BE49-F238E27FC236}">
+                <a16:creationId xmlns:a16="http://schemas.microsoft.com/office/drawing/2014/main" id="{19F9BF86-FE94-4517-B97D-026C7515E589}"/>
+              </a:ext>
+              <a:ext uri="{C183D7F6-B498-43B3-948B-1728B52AA6E4}">
+                <adec:decorative xmlns:adec="http://schemas.microsoft.com/office/drawing/2017/decorative" val="1"/>
+              </a:ext>
+            </a:extLst>
+          </p:cNvPr>
+          <p:cNvSpPr>
+            <a:spLocks noGrp="1" noRot="1" noChangeAspect="1" noMove="1" noResize="1" noEditPoints="1" noAdjustHandles="1" noChangeArrowheads="1" noChangeShapeType="1" noTextEdit="1"/>
+          </p:cNvSpPr>
+          <p:nvPr>
+            <p:extLst>
+              <p:ext uri="{386F3935-93C4-4BCD-93E2-E3B085C9AB24}">
+                <p16:designElem xmlns:p16="http://schemas.microsoft.com/office/powerpoint/2015/main" val="1"/>
+              </p:ext>
+            </p:extLst>
+          </p:nvPr>
+        </p:nvSpPr>
+        <p:spPr>
+          <a:xfrm>
+            <a:off x="0" y="0"/>
+            <a:ext cx="12192000" cy="6858000"/>
+          </a:xfrm>
+          <a:prstGeom prst="rect">
+            <a:avLst/>
+          </a:prstGeom>
+          <a:ln w="12700" cap="flat" cmpd="sng" algn="ctr">
+            <a:noFill/>
+            <a:prstDash val="solid"/>
+            <a:miter lim="800000"/>
+          </a:ln>
+          <a:effectLst/>
+          <a:extLst>
+            <a:ext uri="{91240B29-F687-4F45-9708-019B960494DF}">
+              <a14:hiddenLine xmlns:a14="http://schemas.microsoft.com/office/drawing/2010/main" w="12700" cap="flat" cmpd="sng" algn="ctr">
+                <a:solidFill>
+                  <a:schemeClr val="accent1">
+                    <a:shade val="50000"/>
+                  </a:schemeClr>
+                </a:solidFill>
+                <a:prstDash val="solid"/>
+                <a:miter lim="800000"/>
+              </a14:hiddenLine>
+            </a:ext>
+          </a:extLst>
+        </p:spPr>
+        <p:style>
+          <a:lnRef idx="2">
+            <a:schemeClr val="accent1">
+              <a:shade val="50000"/>
+            </a:schemeClr>
+          </a:lnRef>
+          <a:fillRef idx="1">
+            <a:schemeClr val="accent1"/>
+          </a:fillRef>
+          <a:effectRef idx="0">
+            <a:schemeClr val="accent1"/>
+          </a:effectRef>
+          <a:fontRef idx="minor">
+            <a:schemeClr val="lt1"/>
+          </a:fontRef>
+        </p:style>
+        <p:txBody>
+          <a:bodyPr rtlCol="0" anchor="ctr"/>
+          <a:lstStyle/>
+          <a:p>
+            <a:pPr algn="ctr"/>
+            <a:endParaRPr lang="en-US"/>
+          </a:p>
+        </p:txBody>
+      </p:sp>
       <p:sp>
         <p:nvSpPr>
           <p:cNvPr id="2" name="Title 1">
             <a:extLst>
               <a:ext uri="{FF2B5EF4-FFF2-40B4-BE49-F238E27FC236}">
-                <a16:creationId xmlns:a16="http://schemas.microsoft.com/office/drawing/2014/main" id="{028621CC-814A-D7A9-4BBC-27FE0D235955}"/>
+                <a16:creationId xmlns:a16="http://schemas.microsoft.com/office/drawing/2014/main" id="{56DB60A1-D5E3-B0BD-9F22-7160CF5A8A8B}"/>
               </a:ext>
             </a:extLst>
           </p:cNvPr>
@@ -5487,62 +7056,426 @@
             <p:ph type="title"/>
           </p:nvPr>
         </p:nvSpPr>
-        <p:spPr/>
-        <p:txBody>
-          <a:bodyPr/>
-          <a:lstStyle/>
-          <a:p>
-            <a:r>
-              <a:rPr lang="en-US" dirty="0"/>
-              <a:t>Where PINNs Have the Edge?</a:t>
-            </a:r>
-          </a:p>
-        </p:txBody>
-      </p:sp>
-      <p:sp>
-        <p:nvSpPr>
-          <p:cNvPr id="3" name="Content Placeholder 2">
-            <a:extLst>
-              <a:ext uri="{FF2B5EF4-FFF2-40B4-BE49-F238E27FC236}">
-                <a16:creationId xmlns:a16="http://schemas.microsoft.com/office/drawing/2014/main" id="{D76CBFE0-BFB3-7819-271F-24A0845F1D80}"/>
-              </a:ext>
-            </a:extLst>
-          </p:cNvPr>
-          <p:cNvSpPr>
-            <a:spLocks noGrp="1"/>
-          </p:cNvSpPr>
+        <p:spPr>
+          <a:xfrm>
+            <a:off x="512378" y="3258434"/>
+            <a:ext cx="3509233" cy="3326797"/>
+          </a:xfrm>
+        </p:spPr>
+        <p:txBody>
+          <a:bodyPr vert="horz" lIns="91440" tIns="45720" rIns="91440" bIns="45720" rtlCol="0" anchor="b">
+            <a:normAutofit/>
+          </a:bodyPr>
+          <a:lstStyle/>
+          <a:p>
+            <a:r>
+              <a:rPr lang="en-US" sz="4800" dirty="0"/>
+              <a:t>Taylor Green Vortex Benchmark</a:t>
+            </a:r>
+          </a:p>
+        </p:txBody>
+      </p:sp>
+      <p:pic>
+        <p:nvPicPr>
+          <p:cNvPr id="7" name="Picture 6">
+            <a:extLst>
+              <a:ext uri="{FF2B5EF4-FFF2-40B4-BE49-F238E27FC236}">
+                <a16:creationId xmlns:a16="http://schemas.microsoft.com/office/drawing/2014/main" id="{E77CA4E2-D886-7D24-345D-B24A8E72F040}"/>
+              </a:ext>
+            </a:extLst>
+          </p:cNvPr>
+          <p:cNvPicPr>
+            <a:picLocks noChangeAspect="1"/>
+          </p:cNvPicPr>
+          <p:nvPr/>
+        </p:nvPicPr>
+        <p:blipFill>
+          <a:blip r:embed="rId2"/>
+          <a:stretch>
+            <a:fillRect/>
+          </a:stretch>
+        </p:blipFill>
+        <p:spPr>
+          <a:xfrm>
+            <a:off x="4670171" y="589060"/>
+            <a:ext cx="7495210" cy="5996171"/>
+          </a:xfrm>
+          <a:prstGeom prst="rect">
+            <a:avLst/>
+          </a:prstGeom>
+        </p:spPr>
+      </p:pic>
+      <p:pic>
+        <p:nvPicPr>
+          <p:cNvPr id="5" name="Content Placeholder 4">
+            <a:extLst>
+              <a:ext uri="{FF2B5EF4-FFF2-40B4-BE49-F238E27FC236}">
+                <a16:creationId xmlns:a16="http://schemas.microsoft.com/office/drawing/2014/main" id="{4FCACC49-D9E6-9BF1-A7CD-61C5F4EDA5A5}"/>
+              </a:ext>
+            </a:extLst>
+          </p:cNvPr>
+          <p:cNvPicPr>
+            <a:picLocks noGrp="1" noChangeAspect="1"/>
+          </p:cNvPicPr>
           <p:nvPr>
             <p:ph idx="1"/>
           </p:nvPr>
-        </p:nvSpPr>
-        <p:spPr/>
-        <p:txBody>
-          <a:bodyPr/>
-          <a:lstStyle/>
-          <a:p>
-            <a:endParaRPr lang="en-US"/>
+        </p:nvPicPr>
+        <p:blipFill>
+          <a:blip r:embed="rId3"/>
+          <a:stretch>
+            <a:fillRect/>
+          </a:stretch>
+        </p:blipFill>
+        <p:spPr>
+          <a:xfrm>
+            <a:off x="4533989" y="589060"/>
+            <a:ext cx="7631392" cy="6105116"/>
+          </a:xfrm>
+          <a:prstGeom prst="rect">
+            <a:avLst/>
+          </a:prstGeom>
+        </p:spPr>
+      </p:pic>
+      <p:pic>
+        <p:nvPicPr>
+          <p:cNvPr id="9" name="Picture 8">
+            <a:extLst>
+              <a:ext uri="{FF2B5EF4-FFF2-40B4-BE49-F238E27FC236}">
+                <a16:creationId xmlns:a16="http://schemas.microsoft.com/office/drawing/2014/main" id="{B36CA233-B044-2838-EB47-099AB4D31A31}"/>
+              </a:ext>
+            </a:extLst>
+          </p:cNvPr>
+          <p:cNvPicPr>
+            <a:picLocks noChangeAspect="1"/>
+          </p:cNvPicPr>
+          <p:nvPr/>
+        </p:nvPicPr>
+        <p:blipFill>
+          <a:blip r:embed="rId4"/>
+          <a:stretch>
+            <a:fillRect/>
+          </a:stretch>
+        </p:blipFill>
+        <p:spPr>
+          <a:xfrm>
+            <a:off x="4533989" y="589060"/>
+            <a:ext cx="7631380" cy="6105108"/>
+          </a:xfrm>
+          <a:prstGeom prst="rect">
+            <a:avLst/>
+          </a:prstGeom>
+        </p:spPr>
+      </p:pic>
+      <p:pic>
+        <p:nvPicPr>
+          <p:cNvPr id="11" name="Picture 10">
+            <a:extLst>
+              <a:ext uri="{FF2B5EF4-FFF2-40B4-BE49-F238E27FC236}">
+                <a16:creationId xmlns:a16="http://schemas.microsoft.com/office/drawing/2014/main" id="{E36C09B7-4A20-30AB-03E8-EC149A51E086}"/>
+              </a:ext>
+            </a:extLst>
+          </p:cNvPr>
+          <p:cNvPicPr>
+            <a:picLocks noChangeAspect="1"/>
+          </p:cNvPicPr>
+          <p:nvPr/>
+        </p:nvPicPr>
+        <p:blipFill>
+          <a:blip r:embed="rId5"/>
+          <a:stretch>
+            <a:fillRect/>
+          </a:stretch>
+        </p:blipFill>
+        <p:spPr>
+          <a:xfrm>
+            <a:off x="4507370" y="589052"/>
+            <a:ext cx="7631372" cy="6105099"/>
+          </a:xfrm>
+          <a:prstGeom prst="rect">
+            <a:avLst/>
+          </a:prstGeom>
+        </p:spPr>
+      </p:pic>
+      <p:sp>
+        <p:nvSpPr>
+          <p:cNvPr id="12" name="TextBox 11">
+            <a:extLst>
+              <a:ext uri="{FF2B5EF4-FFF2-40B4-BE49-F238E27FC236}">
+                <a16:creationId xmlns:a16="http://schemas.microsoft.com/office/drawing/2014/main" id="{D4751A91-EA69-EAC6-6D2B-F6542B21CAD9}"/>
+              </a:ext>
+            </a:extLst>
+          </p:cNvPr>
+          <p:cNvSpPr txBox="1"/>
+          <p:nvPr/>
+        </p:nvSpPr>
+        <p:spPr>
+          <a:xfrm>
+            <a:off x="435179" y="1790775"/>
+            <a:ext cx="2513830" cy="707886"/>
+          </a:xfrm>
+          <a:prstGeom prst="rect">
+            <a:avLst/>
+          </a:prstGeom>
+          <a:noFill/>
+        </p:spPr>
+        <p:txBody>
+          <a:bodyPr wrap="none" rtlCol="0">
+            <a:spAutoFit/>
+          </a:bodyPr>
+          <a:lstStyle/>
+          <a:p>
+            <a:r>
+              <a:rPr lang="en-US" sz="4000" b="1" dirty="0" err="1"/>
+              <a:t>openFoam</a:t>
+            </a:r>
+            <a:endParaRPr lang="en-US" sz="4000" b="1" dirty="0"/>
           </a:p>
         </p:txBody>
       </p:sp>
     </p:spTree>
     <p:extLst>
       <p:ext uri="{BB962C8B-B14F-4D97-AF65-F5344CB8AC3E}">
-        <p14:creationId xmlns:p14="http://schemas.microsoft.com/office/powerpoint/2010/main" val="1861428453"/>
+        <p14:creationId xmlns:p14="http://schemas.microsoft.com/office/powerpoint/2010/main" val="3896516673"/>
       </p:ext>
     </p:extLst>
   </p:cSld>
   <p:clrMapOvr>
     <a:masterClrMapping/>
   </p:clrMapOvr>
+  <p:timing>
+    <p:tnLst>
+      <p:par>
+        <p:cTn id="1" dur="indefinite" restart="never" nodeType="tmRoot">
+          <p:childTnLst>
+            <p:seq concurrent="1" nextAc="seek">
+              <p:cTn id="2" dur="indefinite" nodeType="mainSeq">
+                <p:childTnLst>
+                  <p:par>
+                    <p:cTn id="3" fill="hold">
+                      <p:stCondLst>
+                        <p:cond delay="indefinite"/>
+                      </p:stCondLst>
+                      <p:childTnLst>
+                        <p:par>
+                          <p:cTn id="4" fill="hold">
+                            <p:stCondLst>
+                              <p:cond delay="0"/>
+                            </p:stCondLst>
+                            <p:childTnLst>
+                              <p:par>
+                                <p:cTn id="5" presetID="1" presetClass="entr" presetSubtype="0" fill="hold" nodeType="clickEffect">
+                                  <p:stCondLst>
+                                    <p:cond delay="0"/>
+                                  </p:stCondLst>
+                                  <p:childTnLst>
+                                    <p:set>
+                                      <p:cBhvr>
+                                        <p:cTn id="6" dur="1" fill="hold">
+                                          <p:stCondLst>
+                                            <p:cond delay="0"/>
+                                          </p:stCondLst>
+                                        </p:cTn>
+                                        <p:tgtEl>
+                                          <p:spTgt spid="5"/>
+                                        </p:tgtEl>
+                                        <p:attrNameLst>
+                                          <p:attrName>style.visibility</p:attrName>
+                                        </p:attrNameLst>
+                                      </p:cBhvr>
+                                      <p:to>
+                                        <p:strVal val="visible"/>
+                                      </p:to>
+                                    </p:set>
+                                  </p:childTnLst>
+                                </p:cTn>
+                              </p:par>
+                            </p:childTnLst>
+                          </p:cTn>
+                        </p:par>
+                      </p:childTnLst>
+                    </p:cTn>
+                  </p:par>
+                  <p:par>
+                    <p:cTn id="7" fill="hold">
+                      <p:stCondLst>
+                        <p:cond delay="indefinite"/>
+                      </p:stCondLst>
+                      <p:childTnLst>
+                        <p:par>
+                          <p:cTn id="8" fill="hold">
+                            <p:stCondLst>
+                              <p:cond delay="0"/>
+                            </p:stCondLst>
+                            <p:childTnLst>
+                              <p:par>
+                                <p:cTn id="9" presetID="1" presetClass="entr" presetSubtype="0" fill="hold" nodeType="clickEffect">
+                                  <p:stCondLst>
+                                    <p:cond delay="0"/>
+                                  </p:stCondLst>
+                                  <p:childTnLst>
+                                    <p:set>
+                                      <p:cBhvr>
+                                        <p:cTn id="10" dur="1" fill="hold">
+                                          <p:stCondLst>
+                                            <p:cond delay="0"/>
+                                          </p:stCondLst>
+                                        </p:cTn>
+                                        <p:tgtEl>
+                                          <p:spTgt spid="9"/>
+                                        </p:tgtEl>
+                                        <p:attrNameLst>
+                                          <p:attrName>style.visibility</p:attrName>
+                                        </p:attrNameLst>
+                                      </p:cBhvr>
+                                      <p:to>
+                                        <p:strVal val="visible"/>
+                                      </p:to>
+                                    </p:set>
+                                  </p:childTnLst>
+                                </p:cTn>
+                              </p:par>
+                            </p:childTnLst>
+                          </p:cTn>
+                        </p:par>
+                      </p:childTnLst>
+                    </p:cTn>
+                  </p:par>
+                  <p:par>
+                    <p:cTn id="11" fill="hold">
+                      <p:stCondLst>
+                        <p:cond delay="indefinite"/>
+                      </p:stCondLst>
+                      <p:childTnLst>
+                        <p:par>
+                          <p:cTn id="12" fill="hold">
+                            <p:stCondLst>
+                              <p:cond delay="0"/>
+                            </p:stCondLst>
+                            <p:childTnLst>
+                              <p:par>
+                                <p:cTn id="13" presetID="1" presetClass="entr" presetSubtype="0" fill="hold" nodeType="clickEffect">
+                                  <p:stCondLst>
+                                    <p:cond delay="0"/>
+                                  </p:stCondLst>
+                                  <p:childTnLst>
+                                    <p:set>
+                                      <p:cBhvr>
+                                        <p:cTn id="14" dur="1" fill="hold">
+                                          <p:stCondLst>
+                                            <p:cond delay="0"/>
+                                          </p:stCondLst>
+                                        </p:cTn>
+                                        <p:tgtEl>
+                                          <p:spTgt spid="11"/>
+                                        </p:tgtEl>
+                                        <p:attrNameLst>
+                                          <p:attrName>style.visibility</p:attrName>
+                                        </p:attrNameLst>
+                                      </p:cBhvr>
+                                      <p:to>
+                                        <p:strVal val="visible"/>
+                                      </p:to>
+                                    </p:set>
+                                  </p:childTnLst>
+                                </p:cTn>
+                              </p:par>
+                            </p:childTnLst>
+                          </p:cTn>
+                        </p:par>
+                      </p:childTnLst>
+                    </p:cTn>
+                  </p:par>
+                  <p:par>
+                    <p:cTn id="15" fill="hold">
+                      <p:stCondLst>
+                        <p:cond delay="indefinite"/>
+                      </p:stCondLst>
+                      <p:childTnLst>
+                        <p:par>
+                          <p:cTn id="16" fill="hold">
+                            <p:stCondLst>
+                              <p:cond delay="0"/>
+                            </p:stCondLst>
+                            <p:childTnLst>
+                              <p:par>
+                                <p:cTn id="17" presetID="1" presetClass="entr" presetSubtype="0" fill="hold" nodeType="clickEffect">
+                                  <p:stCondLst>
+                                    <p:cond delay="0"/>
+                                  </p:stCondLst>
+                                  <p:childTnLst>
+                                    <p:set>
+                                      <p:cBhvr>
+                                        <p:cTn id="18" dur="1" fill="hold">
+                                          <p:stCondLst>
+                                            <p:cond delay="0"/>
+                                          </p:stCondLst>
+                                        </p:cTn>
+                                        <p:tgtEl>
+                                          <p:spTgt spid="11"/>
+                                        </p:tgtEl>
+                                        <p:attrNameLst>
+                                          <p:attrName>style.visibility</p:attrName>
+                                        </p:attrNameLst>
+                                      </p:cBhvr>
+                                      <p:to>
+                                        <p:strVal val="visible"/>
+                                      </p:to>
+                                    </p:set>
+                                  </p:childTnLst>
+                                </p:cTn>
+                              </p:par>
+                            </p:childTnLst>
+                          </p:cTn>
+                        </p:par>
+                      </p:childTnLst>
+                    </p:cTn>
+                  </p:par>
+                </p:childTnLst>
+              </p:cTn>
+              <p:prevCondLst>
+                <p:cond evt="onPrev" delay="0">
+                  <p:tgtEl>
+                    <p:sldTgt/>
+                  </p:tgtEl>
+                </p:cond>
+              </p:prevCondLst>
+              <p:nextCondLst>
+                <p:cond evt="onNext" delay="0">
+                  <p:tgtEl>
+                    <p:sldTgt/>
+                  </p:tgtEl>
+                </p:cond>
+              </p:nextCondLst>
+            </p:seq>
+          </p:childTnLst>
+        </p:cTn>
+      </p:par>
+    </p:tnLst>
+  </p:timing>
 </p:sld>
 </file>
 
 <file path=ppt/slides/slide9.xml><?xml version="1.0" encoding="utf-8"?>
 <p:sld xmlns:a="http://schemas.openxmlformats.org/drawingml/2006/main" xmlns:r="http://schemas.openxmlformats.org/officeDocument/2006/relationships" xmlns:p="http://schemas.openxmlformats.org/presentationml/2006/main">
   <p:cSld>
+    <p:bg>
+      <p:bgPr>
+        <a:solidFill>
+          <a:schemeClr val="bg1"/>
+        </a:solidFill>
+        <a:effectLst/>
+      </p:bgPr>
+    </p:bg>
     <p:spTree>
       <p:nvGrpSpPr>
-        <p:cNvPr id="1" name=""/>
+        <p:cNvPr id="1" name="">
+          <a:extLst>
+            <a:ext uri="{FF2B5EF4-FFF2-40B4-BE49-F238E27FC236}">
+              <a16:creationId xmlns:a16="http://schemas.microsoft.com/office/drawing/2014/main" id="{09EFF7D0-1DA7-330C-BAB5-59A69546054E}"/>
+            </a:ext>
+          </a:extLst>
+        </p:cNvPr>
         <p:cNvGrpSpPr/>
         <p:nvPr/>
       </p:nvGrpSpPr>
@@ -5554,12 +7487,136 @@
           <a:chExt cx="0" cy="0"/>
         </a:xfrm>
       </p:grpSpPr>
+      <p:cxnSp>
+        <p:nvCxnSpPr>
+          <p:cNvPr id="16" name="Straight Connector 15">
+            <a:extLst>
+              <a:ext uri="{FF2B5EF4-FFF2-40B4-BE49-F238E27FC236}">
+                <a16:creationId xmlns:a16="http://schemas.microsoft.com/office/drawing/2014/main" id="{AD8BCB5B-5555-6CCF-225D-99BDF2A76D2F}"/>
+              </a:ext>
+              <a:ext uri="{C183D7F6-B498-43B3-948B-1728B52AA6E4}">
+                <adec:decorative xmlns:adec="http://schemas.microsoft.com/office/drawing/2017/decorative" val="1"/>
+              </a:ext>
+            </a:extLst>
+          </p:cNvPr>
+          <p:cNvCxnSpPr>
+            <a:cxnSpLocks noGrp="1" noRot="1" noChangeAspect="1" noMove="1" noResize="1" noEditPoints="1" noAdjustHandles="1" noChangeArrowheads="1" noChangeShapeType="1"/>
+          </p:cNvCxnSpPr>
+          <p:nvPr>
+            <p:extLst>
+              <p:ext uri="{386F3935-93C4-4BCD-93E2-E3B085C9AB24}">
+                <p16:designElem xmlns:p16="http://schemas.microsoft.com/office/powerpoint/2015/main" val="1"/>
+              </p:ext>
+            </p:extLst>
+          </p:nvPr>
+        </p:nvCxnSpPr>
+        <p:spPr>
+          <a:xfrm>
+            <a:off x="713232" y="1031001"/>
+            <a:ext cx="978862" cy="0"/>
+          </a:xfrm>
+          <a:prstGeom prst="line">
+            <a:avLst/>
+          </a:prstGeom>
+          <a:ln w="76200"/>
+        </p:spPr>
+        <p:style>
+          <a:lnRef idx="1">
+            <a:schemeClr val="accent1"/>
+          </a:lnRef>
+          <a:fillRef idx="0">
+            <a:schemeClr val="accent1"/>
+          </a:fillRef>
+          <a:effectRef idx="0">
+            <a:schemeClr val="accent1"/>
+          </a:effectRef>
+          <a:fontRef idx="minor">
+            <a:schemeClr val="tx1"/>
+          </a:fontRef>
+        </p:style>
+      </p:cxnSp>
+      <p:sp useBgFill="1">
+        <p:nvSpPr>
+          <p:cNvPr id="18" name="Rectangle 17">
+            <a:extLst>
+              <a:ext uri="{FF2B5EF4-FFF2-40B4-BE49-F238E27FC236}">
+                <a16:creationId xmlns:a16="http://schemas.microsoft.com/office/drawing/2014/main" id="{D1202105-6653-E310-88A6-CAAE98DB8BC6}"/>
+              </a:ext>
+              <a:ext uri="{C183D7F6-B498-43B3-948B-1728B52AA6E4}">
+                <adec:decorative xmlns:adec="http://schemas.microsoft.com/office/drawing/2017/decorative" val="1"/>
+              </a:ext>
+            </a:extLst>
+          </p:cNvPr>
+          <p:cNvSpPr>
+            <a:spLocks noGrp="1" noRot="1" noChangeAspect="1" noMove="1" noResize="1" noEditPoints="1" noAdjustHandles="1" noChangeArrowheads="1" noChangeShapeType="1" noTextEdit="1"/>
+          </p:cNvSpPr>
+          <p:nvPr>
+            <p:extLst>
+              <p:ext uri="{386F3935-93C4-4BCD-93E2-E3B085C9AB24}">
+                <p16:designElem xmlns:p16="http://schemas.microsoft.com/office/powerpoint/2015/main" val="1"/>
+              </p:ext>
+            </p:extLst>
+          </p:nvPr>
+        </p:nvSpPr>
+        <p:spPr>
+          <a:xfrm>
+            <a:off x="0" y="0"/>
+            <a:ext cx="12192000" cy="6858000"/>
+          </a:xfrm>
+          <a:prstGeom prst="rect">
+            <a:avLst/>
+          </a:prstGeom>
+          <a:ln w="12700" cap="flat" cmpd="sng" algn="ctr">
+            <a:noFill/>
+            <a:prstDash val="solid"/>
+            <a:miter lim="800000"/>
+          </a:ln>
+          <a:effectLst/>
+          <a:extLst>
+            <a:ext uri="{91240B29-F687-4F45-9708-019B960494DF}">
+              <a14:hiddenLine xmlns:a14="http://schemas.microsoft.com/office/drawing/2010/main" w="12700" cap="flat" cmpd="sng" algn="ctr">
+                <a:solidFill>
+                  <a:schemeClr val="accent1">
+                    <a:shade val="50000"/>
+                  </a:schemeClr>
+                </a:solidFill>
+                <a:prstDash val="solid"/>
+                <a:miter lim="800000"/>
+              </a14:hiddenLine>
+            </a:ext>
+          </a:extLst>
+        </p:spPr>
+        <p:style>
+          <a:lnRef idx="2">
+            <a:schemeClr val="accent1">
+              <a:shade val="50000"/>
+            </a:schemeClr>
+          </a:lnRef>
+          <a:fillRef idx="1">
+            <a:schemeClr val="accent1"/>
+          </a:fillRef>
+          <a:effectRef idx="0">
+            <a:schemeClr val="accent1"/>
+          </a:effectRef>
+          <a:fontRef idx="minor">
+            <a:schemeClr val="lt1"/>
+          </a:fontRef>
+        </p:style>
+        <p:txBody>
+          <a:bodyPr rtlCol="0" anchor="ctr"/>
+          <a:lstStyle/>
+          <a:p>
+            <a:pPr algn="ctr"/>
+            <a:endParaRPr lang="en-US"/>
+          </a:p>
+        </p:txBody>
+      </p:sp>
       <p:sp>
         <p:nvSpPr>
           <p:cNvPr id="2" name="Title 1">
             <a:extLst>
               <a:ext uri="{FF2B5EF4-FFF2-40B4-BE49-F238E27FC236}">
-                <a16:creationId xmlns:a16="http://schemas.microsoft.com/office/drawing/2014/main" id="{94E9AA2D-D8BC-9FBA-568C-9089539EAC82}"/>
+                <a16:creationId xmlns:a16="http://schemas.microsoft.com/office/drawing/2014/main" id="{A877C020-20C4-A60C-C835-77FD684A8902}"/>
               </a:ext>
             </a:extLst>
           </p:cNvPr>
@@ -5570,24 +7627,66 @@
             <p:ph type="title"/>
           </p:nvPr>
         </p:nvSpPr>
-        <p:spPr/>
-        <p:txBody>
-          <a:bodyPr/>
-          <a:lstStyle/>
-          <a:p>
-            <a:r>
-              <a:rPr lang="en-US" dirty="0"/>
-              <a:t>Collaboration Results</a:t>
-            </a:r>
-          </a:p>
-        </p:txBody>
-      </p:sp>
-      <p:sp>
-        <p:nvSpPr>
-          <p:cNvPr id="3" name="Content Placeholder 2">
-            <a:extLst>
-              <a:ext uri="{FF2B5EF4-FFF2-40B4-BE49-F238E27FC236}">
-                <a16:creationId xmlns:a16="http://schemas.microsoft.com/office/drawing/2014/main" id="{06747A52-6C3E-D967-E643-A05597C6FEC8}"/>
+        <p:spPr>
+          <a:xfrm>
+            <a:off x="350911" y="3111282"/>
+            <a:ext cx="3509233" cy="3326797"/>
+          </a:xfrm>
+        </p:spPr>
+        <p:txBody>
+          <a:bodyPr vert="horz" lIns="91440" tIns="45720" rIns="91440" bIns="45720" rtlCol="0" anchor="b">
+            <a:normAutofit/>
+          </a:bodyPr>
+          <a:lstStyle/>
+          <a:p>
+            <a:r>
+              <a:rPr lang="en-US" sz="4800" dirty="0"/>
+              <a:t>Taylor Green Vortex Benchmark</a:t>
+            </a:r>
+          </a:p>
+        </p:txBody>
+      </p:sp>
+      <p:sp>
+        <p:nvSpPr>
+          <p:cNvPr id="3" name="TextBox 2">
+            <a:extLst>
+              <a:ext uri="{FF2B5EF4-FFF2-40B4-BE49-F238E27FC236}">
+                <a16:creationId xmlns:a16="http://schemas.microsoft.com/office/drawing/2014/main" id="{6F67E9F6-9A46-418B-64AC-38B0991E8B7B}"/>
+              </a:ext>
+            </a:extLst>
+          </p:cNvPr>
+          <p:cNvSpPr txBox="1"/>
+          <p:nvPr/>
+        </p:nvSpPr>
+        <p:spPr>
+          <a:xfrm>
+            <a:off x="437662" y="1983475"/>
+            <a:ext cx="1362874" cy="707886"/>
+          </a:xfrm>
+          <a:prstGeom prst="rect">
+            <a:avLst/>
+          </a:prstGeom>
+          <a:noFill/>
+        </p:spPr>
+        <p:txBody>
+          <a:bodyPr wrap="none" rtlCol="0">
+            <a:spAutoFit/>
+          </a:bodyPr>
+          <a:lstStyle/>
+          <a:p>
+            <a:r>
+              <a:rPr lang="en-US" sz="4000" b="1" dirty="0"/>
+              <a:t>PINN</a:t>
+            </a:r>
+          </a:p>
+        </p:txBody>
+      </p:sp>
+      <p:sp>
+        <p:nvSpPr>
+          <p:cNvPr id="6" name="Content Placeholder 5">
+            <a:extLst>
+              <a:ext uri="{FF2B5EF4-FFF2-40B4-BE49-F238E27FC236}">
+                <a16:creationId xmlns:a16="http://schemas.microsoft.com/office/drawing/2014/main" id="{24E28B5A-C4FE-8944-C1E9-DD17D7154931}"/>
               </a:ext>
             </a:extLst>
           </p:cNvPr>
@@ -5610,7 +7709,7 @@
     </p:spTree>
     <p:extLst>
       <p:ext uri="{BB962C8B-B14F-4D97-AF65-F5344CB8AC3E}">
-        <p14:creationId xmlns:p14="http://schemas.microsoft.com/office/powerpoint/2010/main" val="120589493"/>
+        <p14:creationId xmlns:p14="http://schemas.microsoft.com/office/powerpoint/2010/main" val="1332186539"/>
       </p:ext>
     </p:extLst>
   </p:cSld>

</xml_diff>